<commit_message>
Slides version 3 after review: stats paired with the questions, colours, labels of the two 9.4 % ranges, numeric curve, task map and demo slide, honest notes; variables row 6 updated
</commit_message>
<xml_diff>
--- a/ppt_slide_topics/Sunflower_Weight_Estimation_v3.pptx
+++ b/ppt_slide_topics/Sunflower_Weight_Estimation_v3.pptx
@@ -20,9 +20,10 @@
     <p:sldId id="268" r:id="rId14"/>
     <p:sldId id="269" r:id="rId15"/>
     <p:sldId id="270" r:id="rId16"/>
+    <p:sldId id="271" r:id="rId17"/>
   </p:sldIdLst>
   <p:notesMasterIdLst>
-    <p:notesMasterId r:id="rId17"/>
+    <p:notesMasterId r:id="rId18"/>
   </p:notesMasterIdLst>
   <p:sldSz cx="12192000" cy="6858000"/>
   <p:notesSz cx="6858000" cy="12192000"/>
@@ -706,7 +707,7 @@
                 </a:solidFill>
                 <a:latin typeface="Calibri"/>
               </a:rPr>
-              <a:t>Error budget, 17 piles (relative standard deviation, %)</a:t>
+              <a:t>Error budget, 17 piles (relative standard deviation, %)</a:t>
             </a:r>
           </a:p>
         </c:rich>
@@ -1202,7 +1203,7 @@
               <c:strCache>
                 <c:ptCount val="1"/>
                 <c:pt idx="0">
-                  <c:v>Bound +10 %</c:v>
+                  <c:v>Bound +10 %</c:v>
                 </c:pt>
               </c:strCache>
             </c:strRef>
@@ -1346,7 +1347,7 @@
               <c:strCache>
                 <c:ptCount val="1"/>
                 <c:pt idx="0">
-                  <c:v>Bound -10 %</c:v>
+                  <c:v>Bound -10 %</c:v>
                 </c:pt>
               </c:strCache>
             </c:strRef>
@@ -1674,7 +1675,7 @@
                 </a:solidFill>
                 <a:latin typeface="Calibri"/>
               </a:rPr>
-              <a:t>Range against number of piles (spread 3.97 %)</a:t>
+              <a:t>95 % range for one photo against the number of piles</a:t>
             </a:r>
           </a:p>
         </c:rich>
@@ -1716,7 +1717,7 @@
           </c:spPr>
           <c:invertIfNegative val="0"/>
           <c:dLbls>
-            <c:numFmt formatCode="0.0" sourceLinked="0"/>
+            <c:numFmt formatCode="#,##0" sourceLinked="0"/>
             <c:txPr>
               <a:bodyPr/>
               <a:lstStyle/>
@@ -1731,9 +1732,8 @@
                 </a:pPr>
               </a:p>
             </c:txPr>
-            <c:dLblPos val="t"/>
             <c:showLegendKey val="0"/>
-            <c:showVal val="1"/>
+            <c:showVal val="0"/>
             <c:showCatName val="0"/>
             <c:showSerName val="0"/>
             <c:showPercent val="0"/>
@@ -1741,8 +1741,8 @@
             <c:showLeaderLines val="0"/>
           </c:dLbls>
           <c:marker>
-            <c:symbol val="circle"/>
-            <c:size val="7"/>
+            <c:symbol val="none"/>
+            <c:size val="6"/>
             <c:spPr>
               <a:solidFill>
                 <a:srgbClr val="2D5B3F"/>
@@ -1759,9 +1759,9 @@
           </c:marker>
           <c:cat>
             <c:multiLvlStrRef>
-              <c:f>Sheet1!$A$2:$A$14</c:f>
+              <c:f>Sheet1!$A$2:$A$49</c:f>
               <c:multiLvlStrCache>
-                <c:ptCount val="13"/>
+                <c:ptCount val="48"/>
                 <c:lvl>
                   <c:pt idx="0">
                     <c:v>3</c:v>
@@ -1776,30 +1776,135 @@
                     <c:v>6</c:v>
                   </c:pt>
                   <c:pt idx="4">
+                    <c:v>7</c:v>
+                  </c:pt>
+                  <c:pt idx="5">
                     <c:v>8</c:v>
                   </c:pt>
-                  <c:pt idx="5">
+                  <c:pt idx="6">
+                    <c:v>9</c:v>
+                  </c:pt>
+                  <c:pt idx="7">
                     <c:v>10</c:v>
                   </c:pt>
-                  <c:pt idx="6">
+                  <c:pt idx="8">
+                    <c:v>11</c:v>
+                  </c:pt>
+                  <c:pt idx="9">
                     <c:v>12</c:v>
                   </c:pt>
-                  <c:pt idx="7">
+                  <c:pt idx="10">
+                    <c:v>13</c:v>
+                  </c:pt>
+                  <c:pt idx="11">
+                    <c:v>14</c:v>
+                  </c:pt>
+                  <c:pt idx="12">
                     <c:v>15</c:v>
                   </c:pt>
-                  <c:pt idx="8">
+                  <c:pt idx="13">
+                    <c:v>16</c:v>
+                  </c:pt>
+                  <c:pt idx="14">
                     <c:v>17</c:v>
                   </c:pt>
-                  <c:pt idx="9">
+                  <c:pt idx="15">
+                    <c:v>18</c:v>
+                  </c:pt>
+                  <c:pt idx="16">
+                    <c:v>19</c:v>
+                  </c:pt>
+                  <c:pt idx="17">
                     <c:v>20</c:v>
                   </c:pt>
-                  <c:pt idx="10">
+                  <c:pt idx="18">
+                    <c:v>21</c:v>
+                  </c:pt>
+                  <c:pt idx="19">
+                    <c:v>22</c:v>
+                  </c:pt>
+                  <c:pt idx="20">
+                    <c:v>23</c:v>
+                  </c:pt>
+                  <c:pt idx="21">
+                    <c:v>24</c:v>
+                  </c:pt>
+                  <c:pt idx="22">
                     <c:v>25</c:v>
                   </c:pt>
-                  <c:pt idx="11">
+                  <c:pt idx="23">
+                    <c:v>26</c:v>
+                  </c:pt>
+                  <c:pt idx="24">
+                    <c:v>27</c:v>
+                  </c:pt>
+                  <c:pt idx="25">
+                    <c:v>28</c:v>
+                  </c:pt>
+                  <c:pt idx="26">
+                    <c:v>29</c:v>
+                  </c:pt>
+                  <c:pt idx="27">
                     <c:v>30</c:v>
                   </c:pt>
-                  <c:pt idx="12">
+                  <c:pt idx="28">
+                    <c:v>31</c:v>
+                  </c:pt>
+                  <c:pt idx="29">
+                    <c:v>32</c:v>
+                  </c:pt>
+                  <c:pt idx="30">
+                    <c:v>33</c:v>
+                  </c:pt>
+                  <c:pt idx="31">
+                    <c:v>34</c:v>
+                  </c:pt>
+                  <c:pt idx="32">
+                    <c:v>35</c:v>
+                  </c:pt>
+                  <c:pt idx="33">
+                    <c:v>36</c:v>
+                  </c:pt>
+                  <c:pt idx="34">
+                    <c:v>37</c:v>
+                  </c:pt>
+                  <c:pt idx="35">
+                    <c:v>38</c:v>
+                  </c:pt>
+                  <c:pt idx="36">
+                    <c:v>39</c:v>
+                  </c:pt>
+                  <c:pt idx="37">
+                    <c:v>40</c:v>
+                  </c:pt>
+                  <c:pt idx="38">
+                    <c:v>41</c:v>
+                  </c:pt>
+                  <c:pt idx="39">
+                    <c:v>42</c:v>
+                  </c:pt>
+                  <c:pt idx="40">
+                    <c:v>43</c:v>
+                  </c:pt>
+                  <c:pt idx="41">
+                    <c:v>44</c:v>
+                  </c:pt>
+                  <c:pt idx="42">
+                    <c:v>45</c:v>
+                  </c:pt>
+                  <c:pt idx="43">
+                    <c:v>46</c:v>
+                  </c:pt>
+                  <c:pt idx="44">
+                    <c:v>47</c:v>
+                  </c:pt>
+                  <c:pt idx="45">
+                    <c:v>48</c:v>
+                  </c:pt>
+                  <c:pt idx="46">
+                    <c:v>49</c:v>
+                  </c:pt>
+                  <c:pt idx="47">
                     <c:v>50</c:v>
                   </c:pt>
                 </c:lvl>
@@ -1808,10 +1913,10 @@
           </c:cat>
           <c:val>
             <c:numRef>
-              <c:f>Sheet1!$B$2:$B$14</c:f>
+              <c:f>Sheet1!$B$2:$B$49</c:f>
               <c:numCache>
                 <c:formatCode>General</c:formatCode>
-                <c:ptCount val="13"/>
+                <c:ptCount val="48"/>
                 <c:pt idx="0">
                   <c:v>19.72</c:v>
                 </c:pt>
@@ -1825,30 +1930,135 @@
                   <c:v>11.02</c:v>
                 </c:pt>
                 <c:pt idx="4">
+                  <c:v>10.38</c:v>
+                </c:pt>
+                <c:pt idx="5">
                   <c:v>9.96</c:v>
                 </c:pt>
-                <c:pt idx="5">
+                <c:pt idx="6">
+                  <c:v>9.65</c:v>
+                </c:pt>
+                <c:pt idx="7">
                   <c:v>9.42</c:v>
                 </c:pt>
-                <c:pt idx="6">
+                <c:pt idx="8">
+                  <c:v>9.24</c:v>
+                </c:pt>
+                <c:pt idx="9">
                   <c:v>9.09</c:v>
                 </c:pt>
-                <c:pt idx="7">
+                <c:pt idx="10">
+                  <c:v>8.98</c:v>
+                </c:pt>
+                <c:pt idx="11">
+                  <c:v>8.88</c:v>
+                </c:pt>
+                <c:pt idx="12">
                   <c:v>8.79</c:v>
                 </c:pt>
-                <c:pt idx="8">
+                <c:pt idx="13">
+                  <c:v>8.72</c:v>
+                </c:pt>
+                <c:pt idx="14">
                   <c:v>8.66</c:v>
                 </c:pt>
-                <c:pt idx="9">
+                <c:pt idx="15">
+                  <c:v>8.61</c:v>
+                </c:pt>
+                <c:pt idx="16">
+                  <c:v>8.56</c:v>
+                </c:pt>
+                <c:pt idx="17">
                   <c:v>8.51</c:v>
                 </c:pt>
-                <c:pt idx="10">
+                <c:pt idx="18">
+                  <c:v>8.48</c:v>
+                </c:pt>
+                <c:pt idx="19">
+                  <c:v>8.44</c:v>
+                </c:pt>
+                <c:pt idx="20">
+                  <c:v>8.41</c:v>
+                </c:pt>
+                <c:pt idx="21">
+                  <c:v>8.38</c:v>
+                </c:pt>
+                <c:pt idx="22">
                   <c:v>8.36</c:v>
                 </c:pt>
-                <c:pt idx="11">
+                <c:pt idx="23">
+                  <c:v>8.33</c:v>
+                </c:pt>
+                <c:pt idx="24">
+                  <c:v>8.31</c:v>
+                </c:pt>
+                <c:pt idx="25">
+                  <c:v>8.29</c:v>
+                </c:pt>
+                <c:pt idx="26">
+                  <c:v>8.27</c:v>
+                </c:pt>
+                <c:pt idx="27">
                   <c:v>8.25</c:v>
                 </c:pt>
-                <c:pt idx="12">
+                <c:pt idx="28">
+                  <c:v>8.24</c:v>
+                </c:pt>
+                <c:pt idx="29">
+                  <c:v>8.22</c:v>
+                </c:pt>
+                <c:pt idx="30">
+                  <c:v>8.21</c:v>
+                </c:pt>
+                <c:pt idx="31">
+                  <c:v>8.19</c:v>
+                </c:pt>
+                <c:pt idx="32">
+                  <c:v>8.18</c:v>
+                </c:pt>
+                <c:pt idx="33">
+                  <c:v>8.17</c:v>
+                </c:pt>
+                <c:pt idx="34">
+                  <c:v>8.16</c:v>
+                </c:pt>
+                <c:pt idx="35">
+                  <c:v>8.15</c:v>
+                </c:pt>
+                <c:pt idx="36">
+                  <c:v>8.14</c:v>
+                </c:pt>
+                <c:pt idx="37">
+                  <c:v>8.13</c:v>
+                </c:pt>
+                <c:pt idx="38">
+                  <c:v>8.12</c:v>
+                </c:pt>
+                <c:pt idx="39">
+                  <c:v>8.11</c:v>
+                </c:pt>
+                <c:pt idx="40">
+                  <c:v>8.1</c:v>
+                </c:pt>
+                <c:pt idx="41">
+                  <c:v>8.1</c:v>
+                </c:pt>
+                <c:pt idx="42">
+                  <c:v>8.09</c:v>
+                </c:pt>
+                <c:pt idx="43">
+                  <c:v>8.08</c:v>
+                </c:pt>
+                <c:pt idx="44">
+                  <c:v>8.08</c:v>
+                </c:pt>
+                <c:pt idx="45">
+                  <c:v>8.07</c:v>
+                </c:pt>
+                <c:pt idx="46">
+                  <c:v>8.06</c:v>
+                </c:pt>
+                <c:pt idx="47">
                   <c:v>8.06</c:v>
                 </c:pt>
               </c:numCache>
@@ -1857,7 +2067,7 @@
           <c:smooth val="0"/>
         </c:ser>
         <c:dLbls>
-          <c:numFmt formatCode="0.0" sourceLinked="0"/>
+          <c:numFmt formatCode="#,##0" sourceLinked="0"/>
           <c:txPr>
             <a:bodyPr/>
             <a:lstStyle/>
@@ -1872,9 +2082,8 @@
               </a:pPr>
             </a:p>
           </c:txPr>
-          <c:dLblPos val="t"/>
           <c:showLegendKey val="0"/>
-          <c:showVal val="1"/>
+          <c:showVal val="0"/>
           <c:showCatName val="0"/>
           <c:showSerName val="0"/>
           <c:showPercent val="0"/>
@@ -1914,7 +2123,7 @@
                     </a:solidFill>
                     <a:latin typeface="Arial"/>
                   </a:rPr>
-                  <a:t>number of piles</a:t>
+                  <a:t>number of piles (3 to 50)</a:t>
                 </a:r>
               </a:p>
             </c:rich>
@@ -1955,6 +2164,7 @@
         <c:auto val="1"/>
         <c:lblAlgn val="ctr"/>
         <c:noMultiLvlLbl val="1"/>
+        <c:tickLblSkip val="5"/>
       </c:catAx>
       <c:valAx>
         <c:axId val="2094734552"/>
@@ -1976,6 +2186,35 @@
             </a:ln>
           </c:spPr>
         </c:majorGridlines>
+        <c:title>
+          <c:tx>
+            <c:rich>
+              <a:bodyPr/>
+              <a:lstStyle/>
+              <a:p>
+                <a:pPr>
+                  <a:defRPr sz="1100" b="0" i="0" u="none" strike="noStrike">
+                    <a:solidFill>
+                      <a:srgbClr val="687063"/>
+                    </a:solidFill>
+                    <a:latin typeface="Arial"/>
+                  </a:defRPr>
+                </a:pPr>
+                <a:r>
+                  <a:rPr sz="1100" b="0" i="0" u="none" strike="noStrike">
+                    <a:solidFill>
+                      <a:srgbClr val="687063"/>
+                    </a:solidFill>
+                    <a:latin typeface="Arial"/>
+                  </a:rPr>
+                  <a:t>± %</a:t>
+                </a:r>
+              </a:p>
+            </c:rich>
+          </c:tx>
+          <c:layout/>
+          <c:overlay val="0"/>
+        </c:title>
         <c:numFmt formatCode="General" sourceLinked="0"/>
         <c:majorTickMark val="out"/>
         <c:minorTickMark val="none"/>
@@ -2515,7 +2754,7 @@
           <a:p>
             <a:r>
               <a:rPr lang="en-US" dirty="0"/>
-              <a:t>Jia followed only the written procedure, with her own phone. We applied Hadi's model of 19 October without changing it. All 9 piles fall inside plus or minus 10 %. That supports the bounds; 9 piles cannot prove them. After this test we used all 17 piles together.</a:t>
+              <a:t>Jia followed only the written procedure, with her own phone. We applied Hadi's model of 19 October without changing it. All 9 piles fall inside plus or minus 10 %. That supports the bounds; 9 piles cannot prove them. After this test we used all 17 piles together.</a:t>
             </a:r>
             <a:endParaRPr lang="en-US" dirty="0"/>
           </a:p>
@@ -2691,7 +2930,7 @@
           <a:p>
             <a:r>
               <a:rPr lang="en-US" dirty="0"/>
-              <a:t>A real user will not print our sheet. So when there is no marker, the app measures the seeds themselves and uses them as the ruler. Tested on all our photos: the range grows only from 8.7 to 9.4 %. A coin or a bank card would be better than the seeds, because their size is exactly known; that is the next step.</a:t>
+              <a:t>A real user will not print our sheet. So when there is no marker, the app measures the seeds themselves and uses them as the ruler. Tested on all our photos: the range grows only from 8.7 to 9.4 %. A coin or a bank card would be better than the seeds, because their size is exactly known; that is the next step.</a:t>
             </a:r>
             <a:endParaRPr lang="en-US" dirty="0"/>
           </a:p>
@@ -2779,7 +3018,7 @@
           <a:p>
             <a:r>
               <a:rPr lang="en-US" dirty="0"/>
-              <a:t>Each pile took 12.7 minutes, about 10 euro at an example labour rate. The range shrinks fast up to about 10 piles, then hardly moves: from 10 piles on, one more pile buys less than 0.2 points. That is our stop rule. We kept Jia's piles to test another person and bigger piles, not to shrink the range.</a:t>
+              <a:t>Task 2 asked how many samples we need; this is the answer with costs. Each pile took 12.7 minutes, about 10 euro at an example labour rate; bigger piles took longer. The range shrinks fast up to about 10 piles, then hardly moves. A percentage point is the difference between two percentages, for example from 9.4 to 9.2 % is 0.2 points. Our stop rule: stop when one more pile buys less than 0.2 points. We kept Jia's piles to test another person and bigger piles, not to shrink the range. Honest limit: the curve uses today's spread; with 17 piles that spread itself is still uncertain.</a:t>
             </a:r>
             <a:endParaRPr lang="en-US" dirty="0"/>
           </a:p>
@@ -2955,7 +3194,7 @@
           <a:p>
             <a:r>
               <a:rPr lang="en-US" dirty="0"/>
-              <a:t>Everything in this talk can be reproduced from the repository.</a:t>
+              <a:t>Map from the six course tasks to the slides. Then the demo: CNH takes the photo themselves, following the instructions on the screen.</a:t>
             </a:r>
             <a:endParaRPr lang="en-US" dirty="0"/>
           </a:p>
@@ -2979,6 +3218,94 @@
             <a:fld id="{F7021451-1387-4CA6-816F-3879F97B5CBC}" type="slidenum">
               <a:rPr lang="en-US"/>
               <a:t>15</a:t>
+            </a:fld>
+            <a:endParaRPr lang="en-US"/>
+          </a:p>
+        </p:txBody>
+      </p:sp>
+    </p:spTree>
+    <p:extLst>
+      <p:ext uri="{BB962C8B-B14F-4D97-AF65-F5344CB8AC3E}">
+        <p14:creationId xmlns:p14="http://schemas.microsoft.com/office/powerpoint/2010/main" val="1024086991"/>
+      </p:ext>
+    </p:extLst>
+  </p:cSld>
+  <p:clrMapOvr>
+    <a:masterClrMapping/>
+  </p:clrMapOvr>
+</p:notes>
+</file>
+
+<file path=ppt/notesSlides/notesSlide16.xml><?xml version="1.0" encoding="utf-8"?>
+<p:notes xmlns:a="http://schemas.openxmlformats.org/drawingml/2006/main" xmlns:r="http://schemas.openxmlformats.org/officeDocument/2006/relationships" xmlns:p="http://schemas.openxmlformats.org/presentationml/2006/main">
+  <p:cSld>
+    <p:spTree>
+      <p:nvGrpSpPr>
+        <p:cNvPr id="1" name=""/>
+        <p:cNvGrpSpPr/>
+        <p:nvPr/>
+      </p:nvGrpSpPr>
+      <p:grpSpPr>
+        <a:xfrm>
+          <a:off x="0" y="0"/>
+          <a:ext cx="0" cy="0"/>
+          <a:chOff x="0" y="0"/>
+          <a:chExt cx="0" cy="0"/>
+        </a:xfrm>
+      </p:grpSpPr>
+      <p:sp>
+        <p:nvSpPr>
+          <p:cNvPr id="2" name="Slide Image Placeholder 1"/>
+          <p:cNvSpPr>
+            <a:spLocks noGrp="1" noRot="1" noChangeAspect="1"/>
+          </p:cNvSpPr>
+          <p:nvPr>
+            <p:ph type="sldImg"/>
+          </p:nvPr>
+        </p:nvSpPr>
+        <p:spPr/>
+      </p:sp>
+      <p:sp>
+        <p:nvSpPr>
+          <p:cNvPr id="3" name="Notes Placeholder 2"/>
+          <p:cNvSpPr>
+            <a:spLocks noGrp="1"/>
+          </p:cNvSpPr>
+          <p:nvPr>
+            <p:ph type="body" idx="1"/>
+          </p:nvPr>
+        </p:nvSpPr>
+        <p:spPr/>
+        <p:txBody>
+          <a:bodyPr/>
+          <a:lstStyle/>
+          <a:p>
+            <a:r>
+              <a:rPr lang="en-US" dirty="0"/>
+              <a:t>Everything in this talk can be reproduced from the repository.</a:t>
+            </a:r>
+            <a:endParaRPr lang="en-US" dirty="0"/>
+          </a:p>
+        </p:txBody>
+      </p:sp>
+      <p:sp>
+        <p:nvSpPr>
+          <p:cNvPr id="4" name="Slide Number Placeholder 3"/>
+          <p:cNvSpPr>
+            <a:spLocks noGrp="1"/>
+          </p:cNvSpPr>
+          <p:nvPr>
+            <p:ph type="sldNum" sz="quarter" idx="10"/>
+          </p:nvPr>
+        </p:nvSpPr>
+        <p:spPr/>
+        <p:txBody>
+          <a:bodyPr/>
+          <a:lstStyle/>
+          <a:p>
+            <a:fld id="{F7021451-1387-4CA6-816F-3879F97B5CBC}" type="slidenum">
+              <a:rPr lang="en-US"/>
+              <a:t>16</a:t>
             </a:fld>
             <a:endParaRPr lang="en-US"/>
           </a:p>
@@ -3043,7 +3370,7 @@
           <a:p>
             <a:r>
               <a:rPr lang="en-US" dirty="0"/>
-              <a:t>CNH asked three questions in the class of 19 October. Here are the three short answers; the rest of the talk shows the evidence. Range = 95 % prediction interval: about 19 of 20 true weights fall inside.</a:t>
+              <a:t>CNH asked three questions in the class of 19 October. Here are the three short answers; the rest of the talk shows the evidence. Range = 95 % prediction interval: about 19 of 20 true weights fall inside.</a:t>
             </a:r>
             <a:endParaRPr lang="en-US" dirty="0"/>
           </a:p>
@@ -3483,7 +3810,7 @@
           <a:p>
             <a:r>
               <a:rPr lang="en-US" dirty="0"/>
-              <a:t>CI = confidence interval: the range where the true difference lies with 95 % certainty. All three intervals include zero and are small, so person, phone and height do not change the count in a way we can detect.</a:t>
+              <a:t>CI = confidence interval: the range where the true difference lies with 95 % certainty. All three intervals include zero and are small, so person, phone and height do not change the count in a way we can detect. Analysis of variance compares the differences between the 8 groups with the differences inside each group; p = 0.81 means the group differences are what chance alone would give.</a:t>
             </a:r>
             <a:endParaRPr lang="en-US" dirty="0"/>
           </a:p>
@@ -3659,7 +3986,7 @@
           <a:p>
             <a:r>
               <a:rPr lang="en-US" dirty="0"/>
-              <a:t>Top-down, the 17 piles spread 3.97 %. Bottom-up, the scale step is 1.73 % (calculated) and the photo 0.93 % (measured in the Gauge R&amp;R). What is left, 3.45 %, is a remainder found by subtraction: seed weight and errors we cannot separate. With t for 17 piles the range for one photo is plus or minus 8.7 %.</a:t>
+              <a:t>Top-down, the 17 piles spread 3.97 %. Bottom-up, the scale step is 1.73 % (calculated) and the photo 0.93 % (measured in the Gauge R&amp;R). What is left, 3.45 %, is a remainder found by subtraction: seed weight and errors we cannot separate. With t for 17 piles the range for one photo is plus or minus 8.7 %. Be honest about task 3: because the remainder is found by subtraction, top-down and bottom-up agree by construction. The one stage we measured independently is the detector: on 3 hand-counted batches of 200 seeds it was off by about 1 % (photos without markers, scale estimated).</a:t>
             </a:r>
             <a:endParaRPr lang="en-US" dirty="0"/>
           </a:p>
@@ -5012,7 +5339,7 @@
                 <a:ea typeface="Calibri" pitchFamily="34" charset="-122"/>
                 <a:cs typeface="Calibri" pitchFamily="34" charset="-120"/>
               </a:rPr>
-              <a:t>Average error -1.3 %, mean absolute error 3.4 %.</a:t>
+              <a:t>Average error -1.3 %, mean absolute error 3.4 %.</a:t>
             </a:r>
             <a:endParaRPr lang="en-US" sz="1600" dirty="0"/>
           </a:p>
@@ -5125,7 +5452,7 @@
                 <a:ea typeface="Calibri" pitchFamily="34" charset="-122"/>
                 <a:cs typeface="Calibri" pitchFamily="34" charset="-120"/>
               </a:rPr>
-              <a:t>Jia +1.5 % (95 % CI -2.7 to +5.7 %): no difference found.</a:t>
+              <a:t>Jia +1.5 % (95 % CI -2.7 to +5.7 %): no difference found.</a:t>
             </a:r>
             <a:endParaRPr lang="en-US" sz="1600" dirty="0"/>
           </a:p>
@@ -5210,7 +5537,7 @@
               <a:buNone/>
             </a:pPr>
             <a:r>
-              <a:rPr lang="en-US" sz="1300" dirty="0">
+              <a:rPr lang="en-US" sz="1200" dirty="0">
                 <a:solidFill>
                   <a:srgbClr val="253027"/>
                 </a:solidFill>
@@ -5218,7 +5545,7 @@
                 <a:ea typeface="Calibri" pitchFamily="34" charset="-122"/>
                 <a:cs typeface="Calibri" pitchFamily="34" charset="-120"/>
               </a:rPr>
-              <a:t>T4-02: 14 g before, 12 g after the photos.</a:t>
+              <a:t>T4-02: 14 g before, 12 g after the photos. With the before weight: 8 of 9 inside.</a:t>
             </a:r>
             <a:endParaRPr lang="en-US" sz="1600" dirty="0"/>
           </a:p>
@@ -5635,7 +5962,7 @@
                 <a:ea typeface="Calibri" pitchFamily="34" charset="-122"/>
                 <a:cs typeface="Calibri" pitchFamily="34" charset="-120"/>
               </a:rPr>
-              <a:t>The light says if the photo follows the rules. The range says how exact the ruler is: ±8.7 % with the marker sheet, ±9.4 % with the seeds.</a:t>
+              <a:t>The light says if the photo follows the rules. The range says how exact the ruler is (17 piles): ±8.7 % with the marker sheet, ±9.4 % with the seeds.</a:t>
             </a:r>
             <a:endParaRPr lang="en-US" sz="1500" dirty="0"/>
           </a:p>
@@ -5757,7 +6084,7 @@
                 <a:ea typeface="Calibri" pitchFamily="34" charset="-122"/>
                 <a:cs typeface="Calibri" pitchFamily="34" charset="-120"/>
               </a:rPr>
-              <a:t>Good photo. (Real weight 12 g.)</a:t>
+              <a:t>Good photo.   Real weight: 12 g.</a:t>
             </a:r>
             <a:endParaRPr lang="en-US" sz="1600" dirty="0"/>
           </a:p>
@@ -5848,7 +6175,7 @@
                 <a:ea typeface="Calibri" pitchFamily="34" charset="-122"/>
                 <a:cs typeface="Calibri" pitchFamily="34" charset="-120"/>
               </a:rPr>
-              <a:t>11.9 g   </a:t>
+              <a:t>11.9 g (10.9 to 12.9 g)   </a:t>
             </a:r>
             <a:pPr indent="0" marL="0">
               <a:buNone/>
@@ -5879,7 +6206,7 @@
                 <a:ea typeface="Calibri" pitchFamily="34" charset="-122"/>
                 <a:cs typeface="Calibri" pitchFamily="34" charset="-120"/>
               </a:rPr>
-              <a:t>Seeds too close together: spread them so that no seed touches another. (Real weight 14 g.)</a:t>
+              <a:t>Seeds too close together: spread them so that no seed touches another, and take the photo again.   Real weight: 14 g.</a:t>
             </a:r>
             <a:endParaRPr lang="en-US" sz="1600" dirty="0"/>
           </a:p>
@@ -6001,7 +6328,7 @@
                 <a:ea typeface="Calibri" pitchFamily="34" charset="-122"/>
                 <a:cs typeface="Calibri" pitchFamily="34" charset="-120"/>
               </a:rPr>
-              <a:t>No marker found: the size was estimated from the seeds, so the range is wider.</a:t>
+              <a:t>No marker found: the size was estimated from the seeds, so the range is wider. Put the marker sheet fully in the photo for a more precise result.</a:t>
             </a:r>
             <a:endParaRPr lang="en-US" sz="1600" dirty="0"/>
           </a:p>
@@ -6106,7 +6433,7 @@
                 <a:ea typeface="Calibri" pitchFamily="34" charset="-122"/>
                 <a:cs typeface="Calibri" pitchFamily="34" charset="-120"/>
               </a:rPr>
-              <a:t>Red</a:t>
+              <a:t>Red (example)</a:t>
             </a:r>
             <a:endParaRPr lang="en-US" sz="1600" dirty="0"/>
           </a:p>
@@ -6901,7 +7228,7 @@
                           <a:ea typeface="Calibri" pitchFamily="34" charset="-122"/>
                           <a:cs typeface="Calibri" pitchFamily="34" charset="-120"/>
                         </a:rPr>
-                        <a:t>-1.0 % on average (worst -5.6 %)</a:t>
+                        <a:t>-1.0 % on average (worst ‑5.6 %)</a:t>
                       </a:r>
                       <a:endParaRPr lang="en-US" sz="1400" dirty="0">
                         <a:latin typeface="Calibri" charset="0"/>
@@ -6971,7 +7298,7 @@
                           <a:ea typeface="Calibri" pitchFamily="34" charset="-122"/>
                           <a:cs typeface="Calibri" pitchFamily="34" charset="-120"/>
                         </a:rPr>
-                        <a:t>Range for one photo (17 piles)</a:t>
+                        <a:t>Range for one photo, 17 piles</a:t>
                       </a:r>
                       <a:endParaRPr lang="en-US" sz="1400" dirty="0">
                         <a:latin typeface="Calibri" charset="0"/>
@@ -7039,7 +7366,7 @@
                           <a:ea typeface="Calibri" pitchFamily="34" charset="-122"/>
                           <a:cs typeface="Calibri" pitchFamily="34" charset="-120"/>
                         </a:rPr>
-                        <a:t>±8.7 %</a:t>
+                        <a:t>±8.7 %</a:t>
                       </a:r>
                       <a:endParaRPr lang="en-US" sz="1400" dirty="0">
                         <a:latin typeface="Calibri" charset="0"/>
@@ -7107,7 +7434,7 @@
                           <a:ea typeface="Calibri" pitchFamily="34" charset="-122"/>
                           <a:cs typeface="Calibri" pitchFamily="34" charset="-120"/>
                         </a:rPr>
-                        <a:t>±9.4 %</a:t>
+                        <a:t>±9.4 %</a:t>
                       </a:r>
                       <a:endParaRPr lang="en-US" sz="1400" dirty="0">
                         <a:latin typeface="Calibri" charset="0"/>
@@ -7245,7 +7572,7 @@
                           <a:ea typeface="Calibri" pitchFamily="34" charset="-122"/>
                           <a:cs typeface="Calibri" pitchFamily="34" charset="-120"/>
                         </a:rPr>
-                        <a:t>1.16 %</a:t>
+                        <a:t>1.16 %</a:t>
                       </a:r>
                       <a:endParaRPr lang="en-US" sz="1400" dirty="0">
                         <a:latin typeface="Calibri" charset="0"/>
@@ -7313,7 +7640,7 @@
                           <a:ea typeface="Calibri" pitchFamily="34" charset="-122"/>
                           <a:cs typeface="Calibri" pitchFamily="34" charset="-120"/>
                         </a:rPr>
-                        <a:t>1.22 %</a:t>
+                        <a:t>1.22 %</a:t>
                       </a:r>
                       <a:endParaRPr lang="en-US" sz="1400" dirty="0">
                         <a:latin typeface="Calibri" charset="0"/>
@@ -7451,7 +7778,7 @@
                           <a:ea typeface="Calibri" pitchFamily="34" charset="-122"/>
                           <a:cs typeface="Calibri" pitchFamily="34" charset="-120"/>
                         </a:rPr>
-                        <a:t>-12.6 %</a:t>
+                        <a:t>-12.6 %</a:t>
                       </a:r>
                       <a:endParaRPr lang="en-US" sz="1400" dirty="0">
                         <a:latin typeface="Calibri" charset="0"/>
@@ -7519,7 +7846,7 @@
                           <a:ea typeface="Calibri" pitchFamily="34" charset="-122"/>
                           <a:cs typeface="Calibri" pitchFamily="34" charset="-120"/>
                         </a:rPr>
-                        <a:t>+1.5 %</a:t>
+                        <a:t>+1.5 %</a:t>
                       </a:r>
                       <a:endParaRPr lang="en-US" sz="1400" dirty="0">
                         <a:latin typeface="Calibri" charset="0"/>
@@ -7868,7 +8195,7 @@
                 <a:ea typeface="Calibri" pitchFamily="34" charset="-122"/>
                 <a:cs typeface="Calibri" pitchFamily="34" charset="-120"/>
               </a:rPr>
-              <a:t>The seed length must be known for each crop and seed lot, like grams per seed. A 5 % wrong seed length changed the count by about 1.4 % on average (4 photos, controlled test).</a:t>
+              <a:t>The seed length must be known per crop and seed lot. It varied 11.25 to 11.88 mm between our sessions; on Jia's piles the seeds-as-ruler error was -2.9 % on average. A 5 % wrong seed length changed the count by about 1.4 % (controlled test, 4 photos).</a:t>
             </a:r>
             <a:endParaRPr lang="en-US" sz="1600" dirty="0"/>
           </a:p>
@@ -8033,7 +8360,7 @@
         </p:nvGraphicFramePr>
         <p:xfrm>
           <a:off x="548640" y="1234440"/>
-          <a:ext cx="6766560" cy="4297680"/>
+          <a:ext cx="6766560" cy="4206240"/>
         </p:xfrm>
         <a:graphic xmlns:a="http://schemas.openxmlformats.org/drawingml/2006/main">
           <a:graphicData uri="http://schemas.openxmlformats.org/drawingml/2006/chart">
@@ -8049,8 +8376,8 @@
         </p:nvSpPr>
         <p:spPr>
           <a:xfrm>
-            <a:off x="548640" y="5623560"/>
-            <a:ext cx="6766560" cy="457200"/>
+            <a:off x="548640" y="5486400"/>
+            <a:ext cx="6766560" cy="685800"/>
           </a:xfrm>
           <a:prstGeom prst="rect">
             <a:avLst/>
@@ -8074,7 +8401,7 @@
                 <a:ea typeface="Calibri" pitchFamily="34" charset="-122"/>
                 <a:cs typeface="Calibri" pitchFamily="34" charset="-120"/>
               </a:rPr>
-              <a:t>Never below ±7.8 % with this setup (1 g kitchen scale, one seed lot), however many piles.</a:t>
+              <a:t>8 piles ±10.0 %   |   10 piles ±9.4 %   |   17 piles ±8.7 %   |   never below ±7.8 % (1 g kitchen scale, one seed lot). With only 17 piles the true value at 17 could be ±6.4 to ±13.2 %.</a:t>
             </a:r>
             <a:endParaRPr lang="en-US" sz="1200" dirty="0"/>
           </a:p>
@@ -8159,7 +8486,7 @@
               <a:buNone/>
             </a:pPr>
             <a:r>
-              <a:rPr lang="en-US" sz="1300" dirty="0">
+              <a:rPr lang="en-US" sz="1200" dirty="0">
                 <a:solidFill>
                   <a:srgbClr val="253027"/>
                 </a:solidFill>
@@ -8167,7 +8494,7 @@
                 <a:ea typeface="Calibri" pitchFamily="34" charset="-122"/>
                 <a:cs typeface="Calibri" pitchFamily="34" charset="-120"/>
               </a:rPr>
-              <a:t>12.7 minutes = 10.20 euro (example rate 48.2 euro per hour, Eurostat 2024, Belgium)</a:t>
+              <a:t>10.20 euro (12.7 min, piles of 10 to 24 g) to 17.35 euro (21.6 min, 27 to 34 g). Example rate 48.2 euro per hour, Eurostat 2024, Belgium.</a:t>
             </a:r>
             <a:endParaRPr lang="en-US" sz="1600" dirty="0"/>
           </a:p>
@@ -8252,7 +8579,7 @@
               <a:buNone/>
             </a:pPr>
             <a:r>
-              <a:rPr lang="en-US" sz="1300" dirty="0">
+              <a:rPr lang="en-US" sz="1200" dirty="0">
                 <a:solidFill>
                   <a:srgbClr val="253027"/>
                 </a:solidFill>
@@ -8260,7 +8587,7 @@
                 <a:ea typeface="Calibri" pitchFamily="34" charset="-122"/>
                 <a:cs typeface="Calibri" pitchFamily="34" charset="-120"/>
               </a:rPr>
-              <a:t>±9.4 %, about 2 hours, about 100 euro. After that, 0.1 point costs 5.67 euro or more.</a:t>
+              <a:t>From 10 piles on, one more pile narrows the range by less than 0.2 percentage points: 0.1 point costs 5.67 euro or more, and the price keeps rising.</a:t>
             </a:r>
             <a:endParaRPr lang="en-US" sz="1600" dirty="0"/>
           </a:p>
@@ -8353,7 +8680,7 @@
                 <a:ea typeface="Calibri" pitchFamily="34" charset="-122"/>
                 <a:cs typeface="Calibri" pitchFamily="34" charset="-120"/>
               </a:rPr>
-              <a:t>A 0.01 g scale, and a new calibration (about 10 piles) per seed lot. An extra photo of the same pile costs 0.25 euro but helps little.</a:t>
+              <a:t>A 0.01 g scale, and a new calibration (about 10 piles, about 100 euro) per seed lot. An extra photo of the same pile costs 0.25 euro but helps little.</a:t>
             </a:r>
             <a:endParaRPr lang="en-US" sz="1600" dirty="0"/>
           </a:p>
@@ -8577,7 +8904,7 @@
                 <a:ea typeface="Calibri" pitchFamily="34" charset="-122"/>
                 <a:cs typeface="Calibri" pitchFamily="34" charset="-120"/>
               </a:rPr>
-              <a:t>1  Hand-count a few piles</a:t>
+              <a:t>1  Hand-count piles with markers</a:t>
             </a:r>
             <a:endParaRPr lang="en-US" sz="1600" dirty="0"/>
           </a:p>
@@ -8597,7 +8924,7 @@
                 <a:ea typeface="Calibri" pitchFamily="34" charset="-122"/>
                 <a:cs typeface="Calibri" pitchFamily="34" charset="-120"/>
               </a:rPr>
-              <a:t>Gives the detector error on our own seeds directly.</a:t>
+              <a:t>Our 3 hand-counted batches had no markers: count again with the markers for a clean detector error.</a:t>
             </a:r>
             <a:endParaRPr lang="en-US" sz="1600" dirty="0"/>
           </a:p>
@@ -9213,6 +9540,1723 @@
                 <a:ea typeface="Cambria" pitchFamily="34" charset="-122"/>
                 <a:cs typeface="Cambria" pitchFamily="34" charset="-120"/>
               </a:rPr>
+              <a:t>The six course tasks, and the live demo</a:t>
+            </a:r>
+            <a:endParaRPr lang="en-US" sz="3000" dirty="0"/>
+          </a:p>
+        </p:txBody>
+      </p:sp>
+      <p:sp>
+        <p:nvSpPr>
+          <p:cNvPr id="3" name="Text 1"/>
+          <p:cNvSpPr txBox="1"/>
+          <p:nvPr/>
+        </p:nvSpPr>
+        <p:spPr>
+          <a:xfrm>
+            <a:off x="9692640" y="411480"/>
+            <a:ext cx="2011680" cy="365760"/>
+          </a:xfrm>
+          <a:prstGeom prst="rect">
+            <a:avLst/>
+          </a:prstGeom>
+          <a:noFill/>
+          <a:ln/>
+        </p:spPr>
+        <p:txBody>
+          <a:bodyPr wrap="square" lIns="0" tIns="0" rIns="0" bIns="0" rtlCol="0" anchor="ctr"/>
+          <a:lstStyle/>
+          <a:p>
+            <a:pPr algn="r" indent="0" marL="0">
+              <a:buNone/>
+            </a:pPr>
+            <a:r>
+              <a:rPr lang="en-US" sz="1100" b="1" spc="200" kern="0" dirty="0">
+                <a:solidFill>
+                  <a:srgbClr val="DC8F14"/>
+                </a:solidFill>
+                <a:latin typeface="Calibri" pitchFamily="34" charset="0"/>
+                <a:ea typeface="Calibri" pitchFamily="34" charset="-122"/>
+                <a:cs typeface="Calibri" pitchFamily="34" charset="-120"/>
+              </a:rPr>
+              <a:t>SUMMARY</a:t>
+            </a:r>
+            <a:endParaRPr lang="en-US" sz="1100" dirty="0"/>
+          </a:p>
+        </p:txBody>
+      </p:sp>
+      <p:graphicFrame>
+        <p:nvGraphicFramePr>
+          <p:cNvPr id="16" name="Table 0"/>
+          <p:cNvGraphicFramePr>
+            <a:graphicFrameLocks noGrp="1"/>
+          </p:cNvGraphicFramePr>
+          <p:nvPr>
+            <p:extLst>
+              <p:ext uri="{D42A27DB-BD31-4B8C-83A1-F6EECF244321}">
+                <p14:modId xmlns:p14="http://schemas.microsoft.com/office/powerpoint/2010/main" val="1579011935"/>
+              </p:ext>
+            </p:extLst>
+          </p:nvPr>
+        </p:nvGraphicFramePr>
+        <p:xfrm>
+          <a:off x="548640" y="1280160"/>
+          <a:ext cx="11109960" cy="914400"/>
+        </p:xfrm>
+        <a:graphic>
+          <a:graphicData uri="http://schemas.openxmlformats.org/drawingml/2006/table">
+            <a:tbl>
+              <a:tblPr/>
+              <a:tblGrid>
+                <a:gridCol w="3291840"/>
+                <a:gridCol w="2743200"/>
+                <a:gridCol w="5074920"/>
+              </a:tblGrid>
+              <a:tr h="502920">
+                <a:tc>
+                  <a:txBody>
+                    <a:bodyPr/>
+                    <a:lstStyle/>
+                    <a:p>
+                      <a:pPr indent="0" marL="0">
+                        <a:buNone/>
+                      </a:pPr>
+                      <a:r>
+                        <a:rPr lang="en-US" sz="1400" b="1" dirty="0">
+                          <a:solidFill>
+                            <a:srgbClr val="FFFFFF"/>
+                          </a:solidFill>
+                          <a:latin typeface="Calibri" pitchFamily="34" charset="0"/>
+                          <a:ea typeface="Calibri" pitchFamily="34" charset="-122"/>
+                          <a:cs typeface="Calibri" pitchFamily="34" charset="-120"/>
+                        </a:rPr>
+                        <a:t>Task</a:t>
+                      </a:r>
+                      <a:endParaRPr lang="en-US" sz="1400" dirty="0">
+                        <a:latin typeface="Calibri" charset="0"/>
+                        <a:ea typeface="Calibri" charset="0"/>
+                        <a:cs typeface="Calibri" charset="0"/>
+                      </a:endParaRPr>
+                    </a:p>
+                  </a:txBody>
+                  <a:tcPr marL="91440" marR="91440" marT="45720" marB="45720">
+                    <a:lnL w="9525" cap="flat" cmpd="sng" algn="ctr">
+                      <a:solidFill>
+                        <a:srgbClr val="E6E1D3"/>
+                      </a:solidFill>
+                      <a:prstDash val="solid"/>
+                      <a:round/>
+                      <a:headEnd type="none" w="med" len="med"/>
+                      <a:tailEnd type="none" w="med" len="med"/>
+                    </a:lnL>
+                    <a:lnR w="9525" cap="flat" cmpd="sng" algn="ctr">
+                      <a:solidFill>
+                        <a:srgbClr val="E6E1D3"/>
+                      </a:solidFill>
+                      <a:prstDash val="solid"/>
+                      <a:round/>
+                      <a:headEnd type="none" w="med" len="med"/>
+                      <a:tailEnd type="none" w="med" len="med"/>
+                    </a:lnR>
+                    <a:lnT w="9525" cap="flat" cmpd="sng" algn="ctr">
+                      <a:solidFill>
+                        <a:srgbClr val="E6E1D3"/>
+                      </a:solidFill>
+                      <a:prstDash val="solid"/>
+                      <a:round/>
+                      <a:headEnd type="none" w="med" len="med"/>
+                      <a:tailEnd type="none" w="med" len="med"/>
+                    </a:lnT>
+                    <a:lnB w="9525" cap="flat" cmpd="sng" algn="ctr">
+                      <a:solidFill>
+                        <a:srgbClr val="E6E1D3"/>
+                      </a:solidFill>
+                      <a:prstDash val="solid"/>
+                      <a:round/>
+                      <a:headEnd type="none" w="med" len="med"/>
+                      <a:tailEnd type="none" w="med" len="med"/>
+                    </a:lnB>
+                    <a:solidFill>
+                      <a:srgbClr val="2D5B3F"/>
+                    </a:solidFill>
+                  </a:tcPr>
+                </a:tc>
+                <a:tc>
+                  <a:txBody>
+                    <a:bodyPr/>
+                    <a:lstStyle/>
+                    <a:p>
+                      <a:pPr indent="0" marL="0">
+                        <a:buNone/>
+                      </a:pPr>
+                      <a:r>
+                        <a:rPr lang="en-US" sz="1400" b="1" dirty="0">
+                          <a:solidFill>
+                            <a:srgbClr val="FFFFFF"/>
+                          </a:solidFill>
+                          <a:latin typeface="Calibri" pitchFamily="34" charset="0"/>
+                          <a:ea typeface="Calibri" pitchFamily="34" charset="-122"/>
+                          <a:cs typeface="Calibri" pitchFamily="34" charset="-120"/>
+                        </a:rPr>
+                        <a:t>Where</a:t>
+                      </a:r>
+                      <a:endParaRPr lang="en-US" sz="1400" dirty="0">
+                        <a:latin typeface="Calibri" charset="0"/>
+                        <a:ea typeface="Calibri" charset="0"/>
+                        <a:cs typeface="Calibri" charset="0"/>
+                      </a:endParaRPr>
+                    </a:p>
+                  </a:txBody>
+                  <a:tcPr marL="91440" marR="91440" marT="45720" marB="45720">
+                    <a:lnL w="9525" cap="flat" cmpd="sng" algn="ctr">
+                      <a:solidFill>
+                        <a:srgbClr val="E6E1D3"/>
+                      </a:solidFill>
+                      <a:prstDash val="solid"/>
+                      <a:round/>
+                      <a:headEnd type="none" w="med" len="med"/>
+                      <a:tailEnd type="none" w="med" len="med"/>
+                    </a:lnL>
+                    <a:lnR w="9525" cap="flat" cmpd="sng" algn="ctr">
+                      <a:solidFill>
+                        <a:srgbClr val="E6E1D3"/>
+                      </a:solidFill>
+                      <a:prstDash val="solid"/>
+                      <a:round/>
+                      <a:headEnd type="none" w="med" len="med"/>
+                      <a:tailEnd type="none" w="med" len="med"/>
+                    </a:lnR>
+                    <a:lnT w="9525" cap="flat" cmpd="sng" algn="ctr">
+                      <a:solidFill>
+                        <a:srgbClr val="E6E1D3"/>
+                      </a:solidFill>
+                      <a:prstDash val="solid"/>
+                      <a:round/>
+                      <a:headEnd type="none" w="med" len="med"/>
+                      <a:tailEnd type="none" w="med" len="med"/>
+                    </a:lnT>
+                    <a:lnB w="9525" cap="flat" cmpd="sng" algn="ctr">
+                      <a:solidFill>
+                        <a:srgbClr val="E6E1D3"/>
+                      </a:solidFill>
+                      <a:prstDash val="solid"/>
+                      <a:round/>
+                      <a:headEnd type="none" w="med" len="med"/>
+                      <a:tailEnd type="none" w="med" len="med"/>
+                    </a:lnB>
+                    <a:solidFill>
+                      <a:srgbClr val="2D5B3F"/>
+                    </a:solidFill>
+                  </a:tcPr>
+                </a:tc>
+                <a:tc>
+                  <a:txBody>
+                    <a:bodyPr/>
+                    <a:lstStyle/>
+                    <a:p>
+                      <a:pPr indent="0" marL="0">
+                        <a:buNone/>
+                      </a:pPr>
+                      <a:r>
+                        <a:rPr lang="en-US" sz="1400" b="1" dirty="0">
+                          <a:solidFill>
+                            <a:srgbClr val="FFFFFF"/>
+                          </a:solidFill>
+                          <a:latin typeface="Calibri" pitchFamily="34" charset="0"/>
+                          <a:ea typeface="Calibri" pitchFamily="34" charset="-122"/>
+                          <a:cs typeface="Calibri" pitchFamily="34" charset="-120"/>
+                        </a:rPr>
+                        <a:t>Answer in one line</a:t>
+                      </a:r>
+                      <a:endParaRPr lang="en-US" sz="1400" dirty="0">
+                        <a:latin typeface="Calibri" charset="0"/>
+                        <a:ea typeface="Calibri" charset="0"/>
+                        <a:cs typeface="Calibri" charset="0"/>
+                      </a:endParaRPr>
+                    </a:p>
+                  </a:txBody>
+                  <a:tcPr marL="91440" marR="91440" marT="45720" marB="45720">
+                    <a:lnL w="9525" cap="flat" cmpd="sng" algn="ctr">
+                      <a:solidFill>
+                        <a:srgbClr val="E6E1D3"/>
+                      </a:solidFill>
+                      <a:prstDash val="solid"/>
+                      <a:round/>
+                      <a:headEnd type="none" w="med" len="med"/>
+                      <a:tailEnd type="none" w="med" len="med"/>
+                    </a:lnL>
+                    <a:lnR w="9525" cap="flat" cmpd="sng" algn="ctr">
+                      <a:solidFill>
+                        <a:srgbClr val="E6E1D3"/>
+                      </a:solidFill>
+                      <a:prstDash val="solid"/>
+                      <a:round/>
+                      <a:headEnd type="none" w="med" len="med"/>
+                      <a:tailEnd type="none" w="med" len="med"/>
+                    </a:lnR>
+                    <a:lnT w="9525" cap="flat" cmpd="sng" algn="ctr">
+                      <a:solidFill>
+                        <a:srgbClr val="E6E1D3"/>
+                      </a:solidFill>
+                      <a:prstDash val="solid"/>
+                      <a:round/>
+                      <a:headEnd type="none" w="med" len="med"/>
+                      <a:tailEnd type="none" w="med" len="med"/>
+                    </a:lnT>
+                    <a:lnB w="9525" cap="flat" cmpd="sng" algn="ctr">
+                      <a:solidFill>
+                        <a:srgbClr val="E6E1D3"/>
+                      </a:solidFill>
+                      <a:prstDash val="solid"/>
+                      <a:round/>
+                      <a:headEnd type="none" w="med" len="med"/>
+                      <a:tailEnd type="none" w="med" len="med"/>
+                    </a:lnB>
+                    <a:solidFill>
+                      <a:srgbClr val="2D5B3F"/>
+                    </a:solidFill>
+                  </a:tcPr>
+                </a:tc>
+              </a:tr>
+              <a:tr h="502920">
+                <a:tc>
+                  <a:txBody>
+                    <a:bodyPr/>
+                    <a:lstStyle/>
+                    <a:p>
+                      <a:pPr indent="0" marL="0">
+                        <a:buNone/>
+                      </a:pPr>
+                      <a:r>
+                        <a:rPr lang="en-US" sz="1400" dirty="0">
+                          <a:solidFill>
+                            <a:srgbClr val="253027"/>
+                          </a:solidFill>
+                          <a:latin typeface="Calibri" pitchFamily="34" charset="0"/>
+                          <a:ea typeface="Calibri" pitchFamily="34" charset="-122"/>
+                          <a:cs typeface="Calibri" pitchFamily="34" charset="-120"/>
+                        </a:rPr>
+                        <a:t>1  Plan the collection</a:t>
+                      </a:r>
+                      <a:endParaRPr lang="en-US" sz="1400" dirty="0">
+                        <a:latin typeface="Calibri" charset="0"/>
+                        <a:ea typeface="Calibri" charset="0"/>
+                        <a:cs typeface="Calibri" charset="0"/>
+                      </a:endParaRPr>
+                    </a:p>
+                  </a:txBody>
+                  <a:tcPr marL="91440" marR="91440" marT="45720" marB="45720">
+                    <a:lnL w="9525" cap="flat" cmpd="sng" algn="ctr">
+                      <a:solidFill>
+                        <a:srgbClr val="E6E1D3"/>
+                      </a:solidFill>
+                      <a:prstDash val="solid"/>
+                      <a:round/>
+                      <a:headEnd type="none" w="med" len="med"/>
+                      <a:tailEnd type="none" w="med" len="med"/>
+                    </a:lnL>
+                    <a:lnR w="9525" cap="flat" cmpd="sng" algn="ctr">
+                      <a:solidFill>
+                        <a:srgbClr val="E6E1D3"/>
+                      </a:solidFill>
+                      <a:prstDash val="solid"/>
+                      <a:round/>
+                      <a:headEnd type="none" w="med" len="med"/>
+                      <a:tailEnd type="none" w="med" len="med"/>
+                    </a:lnR>
+                    <a:lnT w="9525" cap="flat" cmpd="sng" algn="ctr">
+                      <a:solidFill>
+                        <a:srgbClr val="E6E1D3"/>
+                      </a:solidFill>
+                      <a:prstDash val="solid"/>
+                      <a:round/>
+                      <a:headEnd type="none" w="med" len="med"/>
+                      <a:tailEnd type="none" w="med" len="med"/>
+                    </a:lnT>
+                    <a:lnB w="9525" cap="flat" cmpd="sng" algn="ctr">
+                      <a:solidFill>
+                        <a:srgbClr val="E6E1D3"/>
+                      </a:solidFill>
+                      <a:prstDash val="solid"/>
+                      <a:round/>
+                      <a:headEnd type="none" w="med" len="med"/>
+                      <a:tailEnd type="none" w="med" len="med"/>
+                    </a:lnB>
+                    <a:solidFill>
+                      <a:srgbClr val="FFFFFF"/>
+                    </a:solidFill>
+                  </a:tcPr>
+                </a:tc>
+                <a:tc>
+                  <a:txBody>
+                    <a:bodyPr/>
+                    <a:lstStyle/>
+                    <a:p>
+                      <a:pPr indent="0" marL="0">
+                        <a:buNone/>
+                      </a:pPr>
+                      <a:r>
+                        <a:rPr lang="en-US" sz="1400" dirty="0">
+                          <a:solidFill>
+                            <a:srgbClr val="253027"/>
+                          </a:solidFill>
+                          <a:latin typeface="Calibri" pitchFamily="34" charset="0"/>
+                          <a:ea typeface="Calibri" pitchFamily="34" charset="-122"/>
+                          <a:cs typeface="Calibri" pitchFamily="34" charset="-120"/>
+                        </a:rPr>
+                        <a:t>Slides 3 to 5</a:t>
+                      </a:r>
+                      <a:endParaRPr lang="en-US" sz="1400" dirty="0">
+                        <a:latin typeface="Calibri" charset="0"/>
+                        <a:ea typeface="Calibri" charset="0"/>
+                        <a:cs typeface="Calibri" charset="0"/>
+                      </a:endParaRPr>
+                    </a:p>
+                  </a:txBody>
+                  <a:tcPr marL="91440" marR="91440" marT="45720" marB="45720">
+                    <a:lnL w="9525" cap="flat" cmpd="sng" algn="ctr">
+                      <a:solidFill>
+                        <a:srgbClr val="E6E1D3"/>
+                      </a:solidFill>
+                      <a:prstDash val="solid"/>
+                      <a:round/>
+                      <a:headEnd type="none" w="med" len="med"/>
+                      <a:tailEnd type="none" w="med" len="med"/>
+                    </a:lnL>
+                    <a:lnR w="9525" cap="flat" cmpd="sng" algn="ctr">
+                      <a:solidFill>
+                        <a:srgbClr val="E6E1D3"/>
+                      </a:solidFill>
+                      <a:prstDash val="solid"/>
+                      <a:round/>
+                      <a:headEnd type="none" w="med" len="med"/>
+                      <a:tailEnd type="none" w="med" len="med"/>
+                    </a:lnR>
+                    <a:lnT w="9525" cap="flat" cmpd="sng" algn="ctr">
+                      <a:solidFill>
+                        <a:srgbClr val="E6E1D3"/>
+                      </a:solidFill>
+                      <a:prstDash val="solid"/>
+                      <a:round/>
+                      <a:headEnd type="none" w="med" len="med"/>
+                      <a:tailEnd type="none" w="med" len="med"/>
+                    </a:lnT>
+                    <a:lnB w="9525" cap="flat" cmpd="sng" algn="ctr">
+                      <a:solidFill>
+                        <a:srgbClr val="E6E1D3"/>
+                      </a:solidFill>
+                      <a:prstDash val="solid"/>
+                      <a:round/>
+                      <a:headEnd type="none" w="med" len="med"/>
+                      <a:tailEnd type="none" w="med" len="med"/>
+                    </a:lnB>
+                    <a:solidFill>
+                      <a:srgbClr val="FFFFFF"/>
+                    </a:solidFill>
+                  </a:tcPr>
+                </a:tc>
+                <a:tc>
+                  <a:txBody>
+                    <a:bodyPr/>
+                    <a:lstStyle/>
+                    <a:p>
+                      <a:pPr indent="0" marL="0">
+                        <a:buNone/>
+                      </a:pPr>
+                      <a:r>
+                        <a:rPr lang="en-US" sz="1400" dirty="0">
+                          <a:solidFill>
+                            <a:srgbClr val="253027"/>
+                          </a:solidFill>
+                          <a:latin typeface="Calibri" pitchFamily="34" charset="0"/>
+                          <a:ea typeface="Calibri" pitchFamily="34" charset="-122"/>
+                          <a:cs typeface="Calibri" pitchFamily="34" charset="-120"/>
+                        </a:rPr>
+                        <a:t>Procedure version 3; every rule from a measured problem</a:t>
+                      </a:r>
+                      <a:endParaRPr lang="en-US" sz="1400" dirty="0">
+                        <a:latin typeface="Calibri" charset="0"/>
+                        <a:ea typeface="Calibri" charset="0"/>
+                        <a:cs typeface="Calibri" charset="0"/>
+                      </a:endParaRPr>
+                    </a:p>
+                  </a:txBody>
+                  <a:tcPr marL="91440" marR="91440" marT="45720" marB="45720">
+                    <a:lnL w="9525" cap="flat" cmpd="sng" algn="ctr">
+                      <a:solidFill>
+                        <a:srgbClr val="E6E1D3"/>
+                      </a:solidFill>
+                      <a:prstDash val="solid"/>
+                      <a:round/>
+                      <a:headEnd type="none" w="med" len="med"/>
+                      <a:tailEnd type="none" w="med" len="med"/>
+                    </a:lnL>
+                    <a:lnR w="9525" cap="flat" cmpd="sng" algn="ctr">
+                      <a:solidFill>
+                        <a:srgbClr val="E6E1D3"/>
+                      </a:solidFill>
+                      <a:prstDash val="solid"/>
+                      <a:round/>
+                      <a:headEnd type="none" w="med" len="med"/>
+                      <a:tailEnd type="none" w="med" len="med"/>
+                    </a:lnR>
+                    <a:lnT w="9525" cap="flat" cmpd="sng" algn="ctr">
+                      <a:solidFill>
+                        <a:srgbClr val="E6E1D3"/>
+                      </a:solidFill>
+                      <a:prstDash val="solid"/>
+                      <a:round/>
+                      <a:headEnd type="none" w="med" len="med"/>
+                      <a:tailEnd type="none" w="med" len="med"/>
+                    </a:lnT>
+                    <a:lnB w="9525" cap="flat" cmpd="sng" algn="ctr">
+                      <a:solidFill>
+                        <a:srgbClr val="E6E1D3"/>
+                      </a:solidFill>
+                      <a:prstDash val="solid"/>
+                      <a:round/>
+                      <a:headEnd type="none" w="med" len="med"/>
+                      <a:tailEnd type="none" w="med" len="med"/>
+                    </a:lnB>
+                    <a:solidFill>
+                      <a:srgbClr val="FFFFFF"/>
+                    </a:solidFill>
+                  </a:tcPr>
+                </a:tc>
+              </a:tr>
+              <a:tr h="502920">
+                <a:tc>
+                  <a:txBody>
+                    <a:bodyPr/>
+                    <a:lstStyle/>
+                    <a:p>
+                      <a:pPr indent="0" marL="0">
+                        <a:buNone/>
+                      </a:pPr>
+                      <a:r>
+                        <a:rPr lang="en-US" sz="1400" dirty="0">
+                          <a:solidFill>
+                            <a:srgbClr val="253027"/>
+                          </a:solidFill>
+                          <a:latin typeface="Calibri" pitchFamily="34" charset="0"/>
+                          <a:ea typeface="Calibri" pitchFamily="34" charset="-122"/>
+                          <a:cs typeface="Calibri" pitchFamily="34" charset="-120"/>
+                        </a:rPr>
+                        <a:t>2  Feature and number of samples</a:t>
+                      </a:r>
+                      <a:endParaRPr lang="en-US" sz="1400" dirty="0">
+                        <a:latin typeface="Calibri" charset="0"/>
+                        <a:ea typeface="Calibri" charset="0"/>
+                        <a:cs typeface="Calibri" charset="0"/>
+                      </a:endParaRPr>
+                    </a:p>
+                  </a:txBody>
+                  <a:tcPr marL="91440" marR="91440" marT="45720" marB="45720">
+                    <a:lnL w="9525" cap="flat" cmpd="sng" algn="ctr">
+                      <a:solidFill>
+                        <a:srgbClr val="E6E1D3"/>
+                      </a:solidFill>
+                      <a:prstDash val="solid"/>
+                      <a:round/>
+                      <a:headEnd type="none" w="med" len="med"/>
+                      <a:tailEnd type="none" w="med" len="med"/>
+                    </a:lnL>
+                    <a:lnR w="9525" cap="flat" cmpd="sng" algn="ctr">
+                      <a:solidFill>
+                        <a:srgbClr val="E6E1D3"/>
+                      </a:solidFill>
+                      <a:prstDash val="solid"/>
+                      <a:round/>
+                      <a:headEnd type="none" w="med" len="med"/>
+                      <a:tailEnd type="none" w="med" len="med"/>
+                    </a:lnR>
+                    <a:lnT w="9525" cap="flat" cmpd="sng" algn="ctr">
+                      <a:solidFill>
+                        <a:srgbClr val="E6E1D3"/>
+                      </a:solidFill>
+                      <a:prstDash val="solid"/>
+                      <a:round/>
+                      <a:headEnd type="none" w="med" len="med"/>
+                      <a:tailEnd type="none" w="med" len="med"/>
+                    </a:lnT>
+                    <a:lnB w="9525" cap="flat" cmpd="sng" algn="ctr">
+                      <a:solidFill>
+                        <a:srgbClr val="E6E1D3"/>
+                      </a:solidFill>
+                      <a:prstDash val="solid"/>
+                      <a:round/>
+                      <a:headEnd type="none" w="med" len="med"/>
+                      <a:tailEnd type="none" w="med" len="med"/>
+                    </a:lnB>
+                    <a:solidFill>
+                      <a:srgbClr val="FFFFFF"/>
+                    </a:solidFill>
+                  </a:tcPr>
+                </a:tc>
+                <a:tc>
+                  <a:txBody>
+                    <a:bodyPr/>
+                    <a:lstStyle/>
+                    <a:p>
+                      <a:pPr indent="0" marL="0">
+                        <a:buNone/>
+                      </a:pPr>
+                      <a:r>
+                        <a:rPr lang="en-US" sz="1400" dirty="0">
+                          <a:solidFill>
+                            <a:srgbClr val="253027"/>
+                          </a:solidFill>
+                          <a:latin typeface="Calibri" pitchFamily="34" charset="0"/>
+                          <a:ea typeface="Calibri" pitchFamily="34" charset="-122"/>
+                          <a:cs typeface="Calibri" pitchFamily="34" charset="-120"/>
+                        </a:rPr>
+                        <a:t>Slides 8 and 13</a:t>
+                      </a:r>
+                      <a:endParaRPr lang="en-US" sz="1400" dirty="0">
+                        <a:latin typeface="Calibri" charset="0"/>
+                        <a:ea typeface="Calibri" charset="0"/>
+                        <a:cs typeface="Calibri" charset="0"/>
+                      </a:endParaRPr>
+                    </a:p>
+                  </a:txBody>
+                  <a:tcPr marL="91440" marR="91440" marT="45720" marB="45720">
+                    <a:lnL w="9525" cap="flat" cmpd="sng" algn="ctr">
+                      <a:solidFill>
+                        <a:srgbClr val="E6E1D3"/>
+                      </a:solidFill>
+                      <a:prstDash val="solid"/>
+                      <a:round/>
+                      <a:headEnd type="none" w="med" len="med"/>
+                      <a:tailEnd type="none" w="med" len="med"/>
+                    </a:lnL>
+                    <a:lnR w="9525" cap="flat" cmpd="sng" algn="ctr">
+                      <a:solidFill>
+                        <a:srgbClr val="E6E1D3"/>
+                      </a:solidFill>
+                      <a:prstDash val="solid"/>
+                      <a:round/>
+                      <a:headEnd type="none" w="med" len="med"/>
+                      <a:tailEnd type="none" w="med" len="med"/>
+                    </a:lnR>
+                    <a:lnT w="9525" cap="flat" cmpd="sng" algn="ctr">
+                      <a:solidFill>
+                        <a:srgbClr val="E6E1D3"/>
+                      </a:solidFill>
+                      <a:prstDash val="solid"/>
+                      <a:round/>
+                      <a:headEnd type="none" w="med" len="med"/>
+                      <a:tailEnd type="none" w="med" len="med"/>
+                    </a:lnT>
+                    <a:lnB w="9525" cap="flat" cmpd="sng" algn="ctr">
+                      <a:solidFill>
+                        <a:srgbClr val="E6E1D3"/>
+                      </a:solidFill>
+                      <a:prstDash val="solid"/>
+                      <a:round/>
+                      <a:headEnd type="none" w="med" len="med"/>
+                      <a:tailEnd type="none" w="med" len="med"/>
+                    </a:lnB>
+                    <a:solidFill>
+                      <a:srgbClr val="FFFFFF"/>
+                    </a:solidFill>
+                  </a:tcPr>
+                </a:tc>
+                <a:tc>
+                  <a:txBody>
+                    <a:bodyPr/>
+                    <a:lstStyle/>
+                    <a:p>
+                      <a:pPr indent="0" marL="0">
+                        <a:buNone/>
+                      </a:pPr>
+                      <a:r>
+                        <a:rPr lang="en-US" sz="1400" dirty="0">
+                          <a:solidFill>
+                            <a:srgbClr val="253027"/>
+                          </a:solidFill>
+                          <a:latin typeface="Calibri" pitchFamily="34" charset="0"/>
+                          <a:ea typeface="Calibri" pitchFamily="34" charset="-122"/>
+                          <a:cs typeface="Calibri" pitchFamily="34" charset="-120"/>
+                        </a:rPr>
+                        <a:t>Count of sunflower boxes; about 10 piles</a:t>
+                      </a:r>
+                      <a:endParaRPr lang="en-US" sz="1400" dirty="0">
+                        <a:latin typeface="Calibri" charset="0"/>
+                        <a:ea typeface="Calibri" charset="0"/>
+                        <a:cs typeface="Calibri" charset="0"/>
+                      </a:endParaRPr>
+                    </a:p>
+                  </a:txBody>
+                  <a:tcPr marL="91440" marR="91440" marT="45720" marB="45720">
+                    <a:lnL w="9525" cap="flat" cmpd="sng" algn="ctr">
+                      <a:solidFill>
+                        <a:srgbClr val="E6E1D3"/>
+                      </a:solidFill>
+                      <a:prstDash val="solid"/>
+                      <a:round/>
+                      <a:headEnd type="none" w="med" len="med"/>
+                      <a:tailEnd type="none" w="med" len="med"/>
+                    </a:lnL>
+                    <a:lnR w="9525" cap="flat" cmpd="sng" algn="ctr">
+                      <a:solidFill>
+                        <a:srgbClr val="E6E1D3"/>
+                      </a:solidFill>
+                      <a:prstDash val="solid"/>
+                      <a:round/>
+                      <a:headEnd type="none" w="med" len="med"/>
+                      <a:tailEnd type="none" w="med" len="med"/>
+                    </a:lnR>
+                    <a:lnT w="9525" cap="flat" cmpd="sng" algn="ctr">
+                      <a:solidFill>
+                        <a:srgbClr val="E6E1D3"/>
+                      </a:solidFill>
+                      <a:prstDash val="solid"/>
+                      <a:round/>
+                      <a:headEnd type="none" w="med" len="med"/>
+                      <a:tailEnd type="none" w="med" len="med"/>
+                    </a:lnT>
+                    <a:lnB w="9525" cap="flat" cmpd="sng" algn="ctr">
+                      <a:solidFill>
+                        <a:srgbClr val="E6E1D3"/>
+                      </a:solidFill>
+                      <a:prstDash val="solid"/>
+                      <a:round/>
+                      <a:headEnd type="none" w="med" len="med"/>
+                      <a:tailEnd type="none" w="med" len="med"/>
+                    </a:lnB>
+                    <a:solidFill>
+                      <a:srgbClr val="FFFFFF"/>
+                    </a:solidFill>
+                  </a:tcPr>
+                </a:tc>
+              </a:tr>
+              <a:tr h="502920">
+                <a:tc>
+                  <a:txBody>
+                    <a:bodyPr/>
+                    <a:lstStyle/>
+                    <a:p>
+                      <a:pPr indent="0" marL="0">
+                        <a:buNone/>
+                      </a:pPr>
+                      <a:r>
+                        <a:rPr lang="en-US" sz="1400" dirty="0">
+                          <a:solidFill>
+                            <a:srgbClr val="253027"/>
+                          </a:solidFill>
+                          <a:latin typeface="Calibri" pitchFamily="34" charset="0"/>
+                          <a:ea typeface="Calibri" pitchFamily="34" charset="-122"/>
+                          <a:cs typeface="Calibri" pitchFamily="34" charset="-120"/>
+                        </a:rPr>
+                        <a:t>3  Bounds and error propagation</a:t>
+                      </a:r>
+                      <a:endParaRPr lang="en-US" sz="1400" dirty="0">
+                        <a:latin typeface="Calibri" charset="0"/>
+                        <a:ea typeface="Calibri" charset="0"/>
+                        <a:cs typeface="Calibri" charset="0"/>
+                      </a:endParaRPr>
+                    </a:p>
+                  </a:txBody>
+                  <a:tcPr marL="91440" marR="91440" marT="45720" marB="45720">
+                    <a:lnL w="9525" cap="flat" cmpd="sng" algn="ctr">
+                      <a:solidFill>
+                        <a:srgbClr val="E6E1D3"/>
+                      </a:solidFill>
+                      <a:prstDash val="solid"/>
+                      <a:round/>
+                      <a:headEnd type="none" w="med" len="med"/>
+                      <a:tailEnd type="none" w="med" len="med"/>
+                    </a:lnL>
+                    <a:lnR w="9525" cap="flat" cmpd="sng" algn="ctr">
+                      <a:solidFill>
+                        <a:srgbClr val="E6E1D3"/>
+                      </a:solidFill>
+                      <a:prstDash val="solid"/>
+                      <a:round/>
+                      <a:headEnd type="none" w="med" len="med"/>
+                      <a:tailEnd type="none" w="med" len="med"/>
+                    </a:lnR>
+                    <a:lnT w="9525" cap="flat" cmpd="sng" algn="ctr">
+                      <a:solidFill>
+                        <a:srgbClr val="E6E1D3"/>
+                      </a:solidFill>
+                      <a:prstDash val="solid"/>
+                      <a:round/>
+                      <a:headEnd type="none" w="med" len="med"/>
+                      <a:tailEnd type="none" w="med" len="med"/>
+                    </a:lnT>
+                    <a:lnB w="9525" cap="flat" cmpd="sng" algn="ctr">
+                      <a:solidFill>
+                        <a:srgbClr val="E6E1D3"/>
+                      </a:solidFill>
+                      <a:prstDash val="solid"/>
+                      <a:round/>
+                      <a:headEnd type="none" w="med" len="med"/>
+                      <a:tailEnd type="none" w="med" len="med"/>
+                    </a:lnB>
+                    <a:solidFill>
+                      <a:srgbClr val="FFFFFF"/>
+                    </a:solidFill>
+                  </a:tcPr>
+                </a:tc>
+                <a:tc>
+                  <a:txBody>
+                    <a:bodyPr/>
+                    <a:lstStyle/>
+                    <a:p>
+                      <a:pPr indent="0" marL="0">
+                        <a:buNone/>
+                      </a:pPr>
+                      <a:r>
+                        <a:rPr lang="en-US" sz="1400" dirty="0">
+                          <a:solidFill>
+                            <a:srgbClr val="253027"/>
+                          </a:solidFill>
+                          <a:latin typeface="Calibri" pitchFamily="34" charset="0"/>
+                          <a:ea typeface="Calibri" pitchFamily="34" charset="-122"/>
+                          <a:cs typeface="Calibri" pitchFamily="34" charset="-120"/>
+                        </a:rPr>
+                        <a:t>Slide 9</a:t>
+                      </a:r>
+                      <a:endParaRPr lang="en-US" sz="1400" dirty="0">
+                        <a:latin typeface="Calibri" charset="0"/>
+                        <a:ea typeface="Calibri" charset="0"/>
+                        <a:cs typeface="Calibri" charset="0"/>
+                      </a:endParaRPr>
+                    </a:p>
+                  </a:txBody>
+                  <a:tcPr marL="91440" marR="91440" marT="45720" marB="45720">
+                    <a:lnL w="9525" cap="flat" cmpd="sng" algn="ctr">
+                      <a:solidFill>
+                        <a:srgbClr val="E6E1D3"/>
+                      </a:solidFill>
+                      <a:prstDash val="solid"/>
+                      <a:round/>
+                      <a:headEnd type="none" w="med" len="med"/>
+                      <a:tailEnd type="none" w="med" len="med"/>
+                    </a:lnL>
+                    <a:lnR w="9525" cap="flat" cmpd="sng" algn="ctr">
+                      <a:solidFill>
+                        <a:srgbClr val="E6E1D3"/>
+                      </a:solidFill>
+                      <a:prstDash val="solid"/>
+                      <a:round/>
+                      <a:headEnd type="none" w="med" len="med"/>
+                      <a:tailEnd type="none" w="med" len="med"/>
+                    </a:lnR>
+                    <a:lnT w="9525" cap="flat" cmpd="sng" algn="ctr">
+                      <a:solidFill>
+                        <a:srgbClr val="E6E1D3"/>
+                      </a:solidFill>
+                      <a:prstDash val="solid"/>
+                      <a:round/>
+                      <a:headEnd type="none" w="med" len="med"/>
+                      <a:tailEnd type="none" w="med" len="med"/>
+                    </a:lnT>
+                    <a:lnB w="9525" cap="flat" cmpd="sng" algn="ctr">
+                      <a:solidFill>
+                        <a:srgbClr val="E6E1D3"/>
+                      </a:solidFill>
+                      <a:prstDash val="solid"/>
+                      <a:round/>
+                      <a:headEnd type="none" w="med" len="med"/>
+                      <a:tailEnd type="none" w="med" len="med"/>
+                    </a:lnB>
+                    <a:solidFill>
+                      <a:srgbClr val="FFFFFF"/>
+                    </a:solidFill>
+                  </a:tcPr>
+                </a:tc>
+                <a:tc>
+                  <a:txBody>
+                    <a:bodyPr/>
+                    <a:lstStyle/>
+                    <a:p>
+                      <a:pPr indent="0" marL="0">
+                        <a:buNone/>
+                      </a:pPr>
+                      <a:r>
+                        <a:rPr lang="en-US" sz="1400" dirty="0">
+                          <a:solidFill>
+                            <a:srgbClr val="253027"/>
+                          </a:solidFill>
+                          <a:latin typeface="Calibri" pitchFamily="34" charset="0"/>
+                          <a:ea typeface="Calibri" pitchFamily="34" charset="-122"/>
+                          <a:cs typeface="Calibri" pitchFamily="34" charset="-120"/>
+                        </a:rPr>
+                        <a:t>±8.7 % for one photo; the photo is not the main error</a:t>
+                      </a:r>
+                      <a:endParaRPr lang="en-US" sz="1400" dirty="0">
+                        <a:latin typeface="Calibri" charset="0"/>
+                        <a:ea typeface="Calibri" charset="0"/>
+                        <a:cs typeface="Calibri" charset="0"/>
+                      </a:endParaRPr>
+                    </a:p>
+                  </a:txBody>
+                  <a:tcPr marL="91440" marR="91440" marT="45720" marB="45720">
+                    <a:lnL w="9525" cap="flat" cmpd="sng" algn="ctr">
+                      <a:solidFill>
+                        <a:srgbClr val="E6E1D3"/>
+                      </a:solidFill>
+                      <a:prstDash val="solid"/>
+                      <a:round/>
+                      <a:headEnd type="none" w="med" len="med"/>
+                      <a:tailEnd type="none" w="med" len="med"/>
+                    </a:lnL>
+                    <a:lnR w="9525" cap="flat" cmpd="sng" algn="ctr">
+                      <a:solidFill>
+                        <a:srgbClr val="E6E1D3"/>
+                      </a:solidFill>
+                      <a:prstDash val="solid"/>
+                      <a:round/>
+                      <a:headEnd type="none" w="med" len="med"/>
+                      <a:tailEnd type="none" w="med" len="med"/>
+                    </a:lnR>
+                    <a:lnT w="9525" cap="flat" cmpd="sng" algn="ctr">
+                      <a:solidFill>
+                        <a:srgbClr val="E6E1D3"/>
+                      </a:solidFill>
+                      <a:prstDash val="solid"/>
+                      <a:round/>
+                      <a:headEnd type="none" w="med" len="med"/>
+                      <a:tailEnd type="none" w="med" len="med"/>
+                    </a:lnT>
+                    <a:lnB w="9525" cap="flat" cmpd="sng" algn="ctr">
+                      <a:solidFill>
+                        <a:srgbClr val="E6E1D3"/>
+                      </a:solidFill>
+                      <a:prstDash val="solid"/>
+                      <a:round/>
+                      <a:headEnd type="none" w="med" len="med"/>
+                      <a:tailEnd type="none" w="med" len="med"/>
+                    </a:lnB>
+                    <a:solidFill>
+                      <a:srgbClr val="FFFFFF"/>
+                    </a:solidFill>
+                  </a:tcPr>
+                </a:tc>
+              </a:tr>
+              <a:tr h="502920">
+                <a:tc>
+                  <a:txBody>
+                    <a:bodyPr/>
+                    <a:lstStyle/>
+                    <a:p>
+                      <a:pPr indent="0" marL="0">
+                        <a:buNone/>
+                      </a:pPr>
+                      <a:r>
+                        <a:rPr lang="en-US" sz="1400" dirty="0">
+                          <a:solidFill>
+                            <a:srgbClr val="253027"/>
+                          </a:solidFill>
+                          <a:latin typeface="Calibri" pitchFamily="34" charset="0"/>
+                          <a:ea typeface="Calibri" pitchFamily="34" charset="-122"/>
+                          <a:cs typeface="Calibri" pitchFamily="34" charset="-120"/>
+                        </a:rPr>
+                        <a:t>4  Team-mate repeats</a:t>
+                      </a:r>
+                      <a:endParaRPr lang="en-US" sz="1400" dirty="0">
+                        <a:latin typeface="Calibri" charset="0"/>
+                        <a:ea typeface="Calibri" charset="0"/>
+                        <a:cs typeface="Calibri" charset="0"/>
+                      </a:endParaRPr>
+                    </a:p>
+                  </a:txBody>
+                  <a:tcPr marL="91440" marR="91440" marT="45720" marB="45720">
+                    <a:lnL w="9525" cap="flat" cmpd="sng" algn="ctr">
+                      <a:solidFill>
+                        <a:srgbClr val="E6E1D3"/>
+                      </a:solidFill>
+                      <a:prstDash val="solid"/>
+                      <a:round/>
+                      <a:headEnd type="none" w="med" len="med"/>
+                      <a:tailEnd type="none" w="med" len="med"/>
+                    </a:lnL>
+                    <a:lnR w="9525" cap="flat" cmpd="sng" algn="ctr">
+                      <a:solidFill>
+                        <a:srgbClr val="E6E1D3"/>
+                      </a:solidFill>
+                      <a:prstDash val="solid"/>
+                      <a:round/>
+                      <a:headEnd type="none" w="med" len="med"/>
+                      <a:tailEnd type="none" w="med" len="med"/>
+                    </a:lnR>
+                    <a:lnT w="9525" cap="flat" cmpd="sng" algn="ctr">
+                      <a:solidFill>
+                        <a:srgbClr val="E6E1D3"/>
+                      </a:solidFill>
+                      <a:prstDash val="solid"/>
+                      <a:round/>
+                      <a:headEnd type="none" w="med" len="med"/>
+                      <a:tailEnd type="none" w="med" len="med"/>
+                    </a:lnT>
+                    <a:lnB w="9525" cap="flat" cmpd="sng" algn="ctr">
+                      <a:solidFill>
+                        <a:srgbClr val="E6E1D3"/>
+                      </a:solidFill>
+                      <a:prstDash val="solid"/>
+                      <a:round/>
+                      <a:headEnd type="none" w="med" len="med"/>
+                      <a:tailEnd type="none" w="med" len="med"/>
+                    </a:lnB>
+                    <a:solidFill>
+                      <a:srgbClr val="FFFFFF"/>
+                    </a:solidFill>
+                  </a:tcPr>
+                </a:tc>
+                <a:tc>
+                  <a:txBody>
+                    <a:bodyPr/>
+                    <a:lstStyle/>
+                    <a:p>
+                      <a:pPr indent="0" marL="0">
+                        <a:buNone/>
+                      </a:pPr>
+                      <a:r>
+                        <a:rPr lang="en-US" sz="1400" dirty="0">
+                          <a:solidFill>
+                            <a:srgbClr val="253027"/>
+                          </a:solidFill>
+                          <a:latin typeface="Calibri" pitchFamily="34" charset="0"/>
+                          <a:ea typeface="Calibri" pitchFamily="34" charset="-122"/>
+                          <a:cs typeface="Calibri" pitchFamily="34" charset="-120"/>
+                        </a:rPr>
+                        <a:t>Slide 10</a:t>
+                      </a:r>
+                      <a:endParaRPr lang="en-US" sz="1400" dirty="0">
+                        <a:latin typeface="Calibri" charset="0"/>
+                        <a:ea typeface="Calibri" charset="0"/>
+                        <a:cs typeface="Calibri" charset="0"/>
+                      </a:endParaRPr>
+                    </a:p>
+                  </a:txBody>
+                  <a:tcPr marL="91440" marR="91440" marT="45720" marB="45720">
+                    <a:lnL w="9525" cap="flat" cmpd="sng" algn="ctr">
+                      <a:solidFill>
+                        <a:srgbClr val="E6E1D3"/>
+                      </a:solidFill>
+                      <a:prstDash val="solid"/>
+                      <a:round/>
+                      <a:headEnd type="none" w="med" len="med"/>
+                      <a:tailEnd type="none" w="med" len="med"/>
+                    </a:lnL>
+                    <a:lnR w="9525" cap="flat" cmpd="sng" algn="ctr">
+                      <a:solidFill>
+                        <a:srgbClr val="E6E1D3"/>
+                      </a:solidFill>
+                      <a:prstDash val="solid"/>
+                      <a:round/>
+                      <a:headEnd type="none" w="med" len="med"/>
+                      <a:tailEnd type="none" w="med" len="med"/>
+                    </a:lnR>
+                    <a:lnT w="9525" cap="flat" cmpd="sng" algn="ctr">
+                      <a:solidFill>
+                        <a:srgbClr val="E6E1D3"/>
+                      </a:solidFill>
+                      <a:prstDash val="solid"/>
+                      <a:round/>
+                      <a:headEnd type="none" w="med" len="med"/>
+                      <a:tailEnd type="none" w="med" len="med"/>
+                    </a:lnT>
+                    <a:lnB w="9525" cap="flat" cmpd="sng" algn="ctr">
+                      <a:solidFill>
+                        <a:srgbClr val="E6E1D3"/>
+                      </a:solidFill>
+                      <a:prstDash val="solid"/>
+                      <a:round/>
+                      <a:headEnd type="none" w="med" len="med"/>
+                      <a:tailEnd type="none" w="med" len="med"/>
+                    </a:lnB>
+                    <a:solidFill>
+                      <a:srgbClr val="FFFFFF"/>
+                    </a:solidFill>
+                  </a:tcPr>
+                </a:tc>
+                <a:tc>
+                  <a:txBody>
+                    <a:bodyPr/>
+                    <a:lstStyle/>
+                    <a:p>
+                      <a:pPr indent="0" marL="0">
+                        <a:buNone/>
+                      </a:pPr>
+                      <a:r>
+                        <a:rPr lang="en-US" sz="1400" dirty="0">
+                          <a:solidFill>
+                            <a:srgbClr val="253027"/>
+                          </a:solidFill>
+                          <a:latin typeface="Calibri" pitchFamily="34" charset="0"/>
+                          <a:ea typeface="Calibri" pitchFamily="34" charset="-122"/>
+                          <a:cs typeface="Calibri" pitchFamily="34" charset="-120"/>
+                        </a:rPr>
+                        <a:t>Jia: 9 of 9 piles inside the bounds</a:t>
+                      </a:r>
+                      <a:endParaRPr lang="en-US" sz="1400" dirty="0">
+                        <a:latin typeface="Calibri" charset="0"/>
+                        <a:ea typeface="Calibri" charset="0"/>
+                        <a:cs typeface="Calibri" charset="0"/>
+                      </a:endParaRPr>
+                    </a:p>
+                  </a:txBody>
+                  <a:tcPr marL="91440" marR="91440" marT="45720" marB="45720">
+                    <a:lnL w="9525" cap="flat" cmpd="sng" algn="ctr">
+                      <a:solidFill>
+                        <a:srgbClr val="E6E1D3"/>
+                      </a:solidFill>
+                      <a:prstDash val="solid"/>
+                      <a:round/>
+                      <a:headEnd type="none" w="med" len="med"/>
+                      <a:tailEnd type="none" w="med" len="med"/>
+                    </a:lnL>
+                    <a:lnR w="9525" cap="flat" cmpd="sng" algn="ctr">
+                      <a:solidFill>
+                        <a:srgbClr val="E6E1D3"/>
+                      </a:solidFill>
+                      <a:prstDash val="solid"/>
+                      <a:round/>
+                      <a:headEnd type="none" w="med" len="med"/>
+                      <a:tailEnd type="none" w="med" len="med"/>
+                    </a:lnR>
+                    <a:lnT w="9525" cap="flat" cmpd="sng" algn="ctr">
+                      <a:solidFill>
+                        <a:srgbClr val="E6E1D3"/>
+                      </a:solidFill>
+                      <a:prstDash val="solid"/>
+                      <a:round/>
+                      <a:headEnd type="none" w="med" len="med"/>
+                      <a:tailEnd type="none" w="med" len="med"/>
+                    </a:lnT>
+                    <a:lnB w="9525" cap="flat" cmpd="sng" algn="ctr">
+                      <a:solidFill>
+                        <a:srgbClr val="E6E1D3"/>
+                      </a:solidFill>
+                      <a:prstDash val="solid"/>
+                      <a:round/>
+                      <a:headEnd type="none" w="med" len="med"/>
+                      <a:tailEnd type="none" w="med" len="med"/>
+                    </a:lnB>
+                    <a:solidFill>
+                      <a:srgbClr val="FFFFFF"/>
+                    </a:solidFill>
+                  </a:tcPr>
+                </a:tc>
+              </a:tr>
+              <a:tr h="502920">
+                <a:tc>
+                  <a:txBody>
+                    <a:bodyPr/>
+                    <a:lstStyle/>
+                    <a:p>
+                      <a:pPr indent="0" marL="0">
+                        <a:buNone/>
+                      </a:pPr>
+                      <a:r>
+                        <a:rPr lang="en-US" sz="1400" dirty="0">
+                          <a:solidFill>
+                            <a:srgbClr val="253027"/>
+                          </a:solidFill>
+                          <a:latin typeface="Calibri" pitchFamily="34" charset="0"/>
+                          <a:ea typeface="Calibri" pitchFamily="34" charset="-122"/>
+                          <a:cs typeface="Calibri" pitchFamily="34" charset="-120"/>
+                        </a:rPr>
+                        <a:t>5  Report</a:t>
+                      </a:r>
+                      <a:endParaRPr lang="en-US" sz="1400" dirty="0">
+                        <a:latin typeface="Calibri" charset="0"/>
+                        <a:ea typeface="Calibri" charset="0"/>
+                        <a:cs typeface="Calibri" charset="0"/>
+                      </a:endParaRPr>
+                    </a:p>
+                  </a:txBody>
+                  <a:tcPr marL="91440" marR="91440" marT="45720" marB="45720">
+                    <a:lnL w="9525" cap="flat" cmpd="sng" algn="ctr">
+                      <a:solidFill>
+                        <a:srgbClr val="E6E1D3"/>
+                      </a:solidFill>
+                      <a:prstDash val="solid"/>
+                      <a:round/>
+                      <a:headEnd type="none" w="med" len="med"/>
+                      <a:tailEnd type="none" w="med" len="med"/>
+                    </a:lnL>
+                    <a:lnR w="9525" cap="flat" cmpd="sng" algn="ctr">
+                      <a:solidFill>
+                        <a:srgbClr val="E6E1D3"/>
+                      </a:solidFill>
+                      <a:prstDash val="solid"/>
+                      <a:round/>
+                      <a:headEnd type="none" w="med" len="med"/>
+                      <a:tailEnd type="none" w="med" len="med"/>
+                    </a:lnR>
+                    <a:lnT w="9525" cap="flat" cmpd="sng" algn="ctr">
+                      <a:solidFill>
+                        <a:srgbClr val="E6E1D3"/>
+                      </a:solidFill>
+                      <a:prstDash val="solid"/>
+                      <a:round/>
+                      <a:headEnd type="none" w="med" len="med"/>
+                      <a:tailEnd type="none" w="med" len="med"/>
+                    </a:lnT>
+                    <a:lnB w="9525" cap="flat" cmpd="sng" algn="ctr">
+                      <a:solidFill>
+                        <a:srgbClr val="E6E1D3"/>
+                      </a:solidFill>
+                      <a:prstDash val="solid"/>
+                      <a:round/>
+                      <a:headEnd type="none" w="med" len="med"/>
+                      <a:tailEnd type="none" w="med" len="med"/>
+                    </a:lnB>
+                    <a:solidFill>
+                      <a:srgbClr val="FFFFFF"/>
+                    </a:solidFill>
+                  </a:tcPr>
+                </a:tc>
+                <a:tc>
+                  <a:txBody>
+                    <a:bodyPr/>
+                    <a:lstStyle/>
+                    <a:p>
+                      <a:pPr indent="0" marL="0">
+                        <a:buNone/>
+                      </a:pPr>
+                      <a:r>
+                        <a:rPr lang="en-US" sz="1400" dirty="0">
+                          <a:solidFill>
+                            <a:srgbClr val="253027"/>
+                          </a:solidFill>
+                          <a:latin typeface="Calibri" pitchFamily="34" charset="0"/>
+                          <a:ea typeface="Calibri" pitchFamily="34" charset="-122"/>
+                          <a:cs typeface="Calibri" pitchFamily="34" charset="-120"/>
+                        </a:rPr>
+                        <a:t>This deck and the repository</a:t>
+                      </a:r>
+                      <a:endParaRPr lang="en-US" sz="1400" dirty="0">
+                        <a:latin typeface="Calibri" charset="0"/>
+                        <a:ea typeface="Calibri" charset="0"/>
+                        <a:cs typeface="Calibri" charset="0"/>
+                      </a:endParaRPr>
+                    </a:p>
+                  </a:txBody>
+                  <a:tcPr marL="91440" marR="91440" marT="45720" marB="45720">
+                    <a:lnL w="9525" cap="flat" cmpd="sng" algn="ctr">
+                      <a:solidFill>
+                        <a:srgbClr val="E6E1D3"/>
+                      </a:solidFill>
+                      <a:prstDash val="solid"/>
+                      <a:round/>
+                      <a:headEnd type="none" w="med" len="med"/>
+                      <a:tailEnd type="none" w="med" len="med"/>
+                    </a:lnL>
+                    <a:lnR w="9525" cap="flat" cmpd="sng" algn="ctr">
+                      <a:solidFill>
+                        <a:srgbClr val="E6E1D3"/>
+                      </a:solidFill>
+                      <a:prstDash val="solid"/>
+                      <a:round/>
+                      <a:headEnd type="none" w="med" len="med"/>
+                      <a:tailEnd type="none" w="med" len="med"/>
+                    </a:lnR>
+                    <a:lnT w="9525" cap="flat" cmpd="sng" algn="ctr">
+                      <a:solidFill>
+                        <a:srgbClr val="E6E1D3"/>
+                      </a:solidFill>
+                      <a:prstDash val="solid"/>
+                      <a:round/>
+                      <a:headEnd type="none" w="med" len="med"/>
+                      <a:tailEnd type="none" w="med" len="med"/>
+                    </a:lnT>
+                    <a:lnB w="9525" cap="flat" cmpd="sng" algn="ctr">
+                      <a:solidFill>
+                        <a:srgbClr val="E6E1D3"/>
+                      </a:solidFill>
+                      <a:prstDash val="solid"/>
+                      <a:round/>
+                      <a:headEnd type="none" w="med" len="med"/>
+                      <a:tailEnd type="none" w="med" len="med"/>
+                    </a:lnB>
+                    <a:solidFill>
+                      <a:srgbClr val="FFFFFF"/>
+                    </a:solidFill>
+                  </a:tcPr>
+                </a:tc>
+                <a:tc>
+                  <a:txBody>
+                    <a:bodyPr/>
+                    <a:lstStyle/>
+                    <a:p>
+                      <a:pPr indent="0" marL="0">
+                        <a:buNone/>
+                      </a:pPr>
+                      <a:r>
+                        <a:rPr lang="en-US" sz="1400" dirty="0">
+                          <a:solidFill>
+                            <a:srgbClr val="253027"/>
+                          </a:solidFill>
+                          <a:latin typeface="Calibri" pitchFamily="34" charset="0"/>
+                          <a:ea typeface="Calibri" pitchFamily="34" charset="-122"/>
+                          <a:cs typeface="Calibri" pitchFamily="34" charset="-120"/>
+                        </a:rPr>
+                        <a:t>All numbers can be rebuilt from the code</a:t>
+                      </a:r>
+                      <a:endParaRPr lang="en-US" sz="1400" dirty="0">
+                        <a:latin typeface="Calibri" charset="0"/>
+                        <a:ea typeface="Calibri" charset="0"/>
+                        <a:cs typeface="Calibri" charset="0"/>
+                      </a:endParaRPr>
+                    </a:p>
+                  </a:txBody>
+                  <a:tcPr marL="91440" marR="91440" marT="45720" marB="45720">
+                    <a:lnL w="9525" cap="flat" cmpd="sng" algn="ctr">
+                      <a:solidFill>
+                        <a:srgbClr val="E6E1D3"/>
+                      </a:solidFill>
+                      <a:prstDash val="solid"/>
+                      <a:round/>
+                      <a:headEnd type="none" w="med" len="med"/>
+                      <a:tailEnd type="none" w="med" len="med"/>
+                    </a:lnL>
+                    <a:lnR w="9525" cap="flat" cmpd="sng" algn="ctr">
+                      <a:solidFill>
+                        <a:srgbClr val="E6E1D3"/>
+                      </a:solidFill>
+                      <a:prstDash val="solid"/>
+                      <a:round/>
+                      <a:headEnd type="none" w="med" len="med"/>
+                      <a:tailEnd type="none" w="med" len="med"/>
+                    </a:lnR>
+                    <a:lnT w="9525" cap="flat" cmpd="sng" algn="ctr">
+                      <a:solidFill>
+                        <a:srgbClr val="E6E1D3"/>
+                      </a:solidFill>
+                      <a:prstDash val="solid"/>
+                      <a:round/>
+                      <a:headEnd type="none" w="med" len="med"/>
+                      <a:tailEnd type="none" w="med" len="med"/>
+                    </a:lnT>
+                    <a:lnB w="9525" cap="flat" cmpd="sng" algn="ctr">
+                      <a:solidFill>
+                        <a:srgbClr val="E6E1D3"/>
+                      </a:solidFill>
+                      <a:prstDash val="solid"/>
+                      <a:round/>
+                      <a:headEnd type="none" w="med" len="med"/>
+                      <a:tailEnd type="none" w="med" len="med"/>
+                    </a:lnB>
+                    <a:solidFill>
+                      <a:srgbClr val="FFFFFF"/>
+                    </a:solidFill>
+                  </a:tcPr>
+                </a:tc>
+              </a:tr>
+              <a:tr h="502920">
+                <a:tc>
+                  <a:txBody>
+                    <a:bodyPr/>
+                    <a:lstStyle/>
+                    <a:p>
+                      <a:pPr indent="0" marL="0">
+                        <a:buNone/>
+                      </a:pPr>
+                      <a:r>
+                        <a:rPr lang="en-US" sz="1400" dirty="0">
+                          <a:solidFill>
+                            <a:srgbClr val="253027"/>
+                          </a:solidFill>
+                          <a:latin typeface="Calibri" pitchFamily="34" charset="0"/>
+                          <a:ea typeface="Calibri" pitchFamily="34" charset="-122"/>
+                          <a:cs typeface="Calibri" pitchFamily="34" charset="-120"/>
+                        </a:rPr>
+                        <a:t>6  Deployment</a:t>
+                      </a:r>
+                      <a:endParaRPr lang="en-US" sz="1400" dirty="0">
+                        <a:latin typeface="Calibri" charset="0"/>
+                        <a:ea typeface="Calibri" charset="0"/>
+                        <a:cs typeface="Calibri" charset="0"/>
+                      </a:endParaRPr>
+                    </a:p>
+                  </a:txBody>
+                  <a:tcPr marL="91440" marR="91440" marT="45720" marB="45720">
+                    <a:lnL w="9525" cap="flat" cmpd="sng" algn="ctr">
+                      <a:solidFill>
+                        <a:srgbClr val="E6E1D3"/>
+                      </a:solidFill>
+                      <a:prstDash val="solid"/>
+                      <a:round/>
+                      <a:headEnd type="none" w="med" len="med"/>
+                      <a:tailEnd type="none" w="med" len="med"/>
+                    </a:lnL>
+                    <a:lnR w="9525" cap="flat" cmpd="sng" algn="ctr">
+                      <a:solidFill>
+                        <a:srgbClr val="E6E1D3"/>
+                      </a:solidFill>
+                      <a:prstDash val="solid"/>
+                      <a:round/>
+                      <a:headEnd type="none" w="med" len="med"/>
+                      <a:tailEnd type="none" w="med" len="med"/>
+                    </a:lnR>
+                    <a:lnT w="9525" cap="flat" cmpd="sng" algn="ctr">
+                      <a:solidFill>
+                        <a:srgbClr val="E6E1D3"/>
+                      </a:solidFill>
+                      <a:prstDash val="solid"/>
+                      <a:round/>
+                      <a:headEnd type="none" w="med" len="med"/>
+                      <a:tailEnd type="none" w="med" len="med"/>
+                    </a:lnT>
+                    <a:lnB w="9525" cap="flat" cmpd="sng" algn="ctr">
+                      <a:solidFill>
+                        <a:srgbClr val="E6E1D3"/>
+                      </a:solidFill>
+                      <a:prstDash val="solid"/>
+                      <a:round/>
+                      <a:headEnd type="none" w="med" len="med"/>
+                      <a:tailEnd type="none" w="med" len="med"/>
+                    </a:lnB>
+                    <a:solidFill>
+                      <a:srgbClr val="FFFFFF"/>
+                    </a:solidFill>
+                  </a:tcPr>
+                </a:tc>
+                <a:tc>
+                  <a:txBody>
+                    <a:bodyPr/>
+                    <a:lstStyle/>
+                    <a:p>
+                      <a:pPr indent="0" marL="0">
+                        <a:buNone/>
+                      </a:pPr>
+                      <a:r>
+                        <a:rPr lang="en-US" sz="1400" dirty="0">
+                          <a:solidFill>
+                            <a:srgbClr val="253027"/>
+                          </a:solidFill>
+                          <a:latin typeface="Calibri" pitchFamily="34" charset="0"/>
+                          <a:ea typeface="Calibri" pitchFamily="34" charset="-122"/>
+                          <a:cs typeface="Calibri" pitchFamily="34" charset="-120"/>
+                        </a:rPr>
+                        <a:t>Now: live demo</a:t>
+                      </a:r>
+                      <a:endParaRPr lang="en-US" sz="1400" dirty="0">
+                        <a:latin typeface="Calibri" charset="0"/>
+                        <a:ea typeface="Calibri" charset="0"/>
+                        <a:cs typeface="Calibri" charset="0"/>
+                      </a:endParaRPr>
+                    </a:p>
+                  </a:txBody>
+                  <a:tcPr marL="91440" marR="91440" marT="45720" marB="45720">
+                    <a:lnL w="9525" cap="flat" cmpd="sng" algn="ctr">
+                      <a:solidFill>
+                        <a:srgbClr val="E6E1D3"/>
+                      </a:solidFill>
+                      <a:prstDash val="solid"/>
+                      <a:round/>
+                      <a:headEnd type="none" w="med" len="med"/>
+                      <a:tailEnd type="none" w="med" len="med"/>
+                    </a:lnL>
+                    <a:lnR w="9525" cap="flat" cmpd="sng" algn="ctr">
+                      <a:solidFill>
+                        <a:srgbClr val="E6E1D3"/>
+                      </a:solidFill>
+                      <a:prstDash val="solid"/>
+                      <a:round/>
+                      <a:headEnd type="none" w="med" len="med"/>
+                      <a:tailEnd type="none" w="med" len="med"/>
+                    </a:lnR>
+                    <a:lnT w="9525" cap="flat" cmpd="sng" algn="ctr">
+                      <a:solidFill>
+                        <a:srgbClr val="E6E1D3"/>
+                      </a:solidFill>
+                      <a:prstDash val="solid"/>
+                      <a:round/>
+                      <a:headEnd type="none" w="med" len="med"/>
+                      <a:tailEnd type="none" w="med" len="med"/>
+                    </a:lnT>
+                    <a:lnB w="9525" cap="flat" cmpd="sng" algn="ctr">
+                      <a:solidFill>
+                        <a:srgbClr val="E6E1D3"/>
+                      </a:solidFill>
+                      <a:prstDash val="solid"/>
+                      <a:round/>
+                      <a:headEnd type="none" w="med" len="med"/>
+                      <a:tailEnd type="none" w="med" len="med"/>
+                    </a:lnB>
+                    <a:solidFill>
+                      <a:srgbClr val="FFFFFF"/>
+                    </a:solidFill>
+                  </a:tcPr>
+                </a:tc>
+                <a:tc>
+                  <a:txBody>
+                    <a:bodyPr/>
+                    <a:lstStyle/>
+                    <a:p>
+                      <a:pPr indent="0" marL="0">
+                        <a:buNone/>
+                      </a:pPr>
+                      <a:r>
+                        <a:rPr lang="en-US" sz="1400" dirty="0">
+                          <a:solidFill>
+                            <a:srgbClr val="253027"/>
+                          </a:solidFill>
+                          <a:latin typeface="Calibri" pitchFamily="34" charset="0"/>
+                          <a:ea typeface="Calibri" pitchFamily="34" charset="-122"/>
+                          <a:cs typeface="Calibri" pitchFamily="34" charset="-120"/>
+                        </a:rPr>
+                        <a:t>You take a photo with your phone, following the instructions in the app</a:t>
+                      </a:r>
+                      <a:endParaRPr lang="en-US" sz="1400" dirty="0">
+                        <a:latin typeface="Calibri" charset="0"/>
+                        <a:ea typeface="Calibri" charset="0"/>
+                        <a:cs typeface="Calibri" charset="0"/>
+                      </a:endParaRPr>
+                    </a:p>
+                  </a:txBody>
+                  <a:tcPr marL="91440" marR="91440" marT="45720" marB="45720">
+                    <a:lnL w="9525" cap="flat" cmpd="sng" algn="ctr">
+                      <a:solidFill>
+                        <a:srgbClr val="E6E1D3"/>
+                      </a:solidFill>
+                      <a:prstDash val="solid"/>
+                      <a:round/>
+                      <a:headEnd type="none" w="med" len="med"/>
+                      <a:tailEnd type="none" w="med" len="med"/>
+                    </a:lnL>
+                    <a:lnR w="9525" cap="flat" cmpd="sng" algn="ctr">
+                      <a:solidFill>
+                        <a:srgbClr val="E6E1D3"/>
+                      </a:solidFill>
+                      <a:prstDash val="solid"/>
+                      <a:round/>
+                      <a:headEnd type="none" w="med" len="med"/>
+                      <a:tailEnd type="none" w="med" len="med"/>
+                    </a:lnR>
+                    <a:lnT w="9525" cap="flat" cmpd="sng" algn="ctr">
+                      <a:solidFill>
+                        <a:srgbClr val="E6E1D3"/>
+                      </a:solidFill>
+                      <a:prstDash val="solid"/>
+                      <a:round/>
+                      <a:headEnd type="none" w="med" len="med"/>
+                      <a:tailEnd type="none" w="med" len="med"/>
+                    </a:lnT>
+                    <a:lnB w="9525" cap="flat" cmpd="sng" algn="ctr">
+                      <a:solidFill>
+                        <a:srgbClr val="E6E1D3"/>
+                      </a:solidFill>
+                      <a:prstDash val="solid"/>
+                      <a:round/>
+                      <a:headEnd type="none" w="med" len="med"/>
+                      <a:tailEnd type="none" w="med" len="med"/>
+                    </a:lnB>
+                    <a:solidFill>
+                      <a:srgbClr val="FFFFFF"/>
+                    </a:solidFill>
+                  </a:tcPr>
+                </a:tc>
+              </a:tr>
+            </a:tbl>
+          </a:graphicData>
+        </a:graphic>
+      </p:graphicFrame>
+      <p:sp>
+        <p:nvSpPr>
+          <p:cNvPr id="5" name="Shape 2"/>
+          <p:cNvSpPr/>
+          <p:nvPr/>
+        </p:nvSpPr>
+        <p:spPr>
+          <a:xfrm>
+            <a:off x="548640" y="5074920"/>
+            <a:ext cx="11109960" cy="1097280"/>
+          </a:xfrm>
+          <a:prstGeom prst="roundRect">
+            <a:avLst>
+              <a:gd name="adj" fmla="val 10000"/>
+            </a:avLst>
+          </a:prstGeom>
+          <a:solidFill>
+            <a:srgbClr val="FFF1BE"/>
+          </a:solidFill>
+          <a:ln w="9525">
+            <a:solidFill>
+              <a:srgbClr val="FFF1BE"/>
+            </a:solidFill>
+            <a:prstDash val="solid"/>
+          </a:ln>
+          <a:effectLst>
+            <a:outerShdw sx="100000" sy="100000" kx="0" ky="0" algn="bl" rotWithShape="0" blurRad="50800" dist="19050" dir="5400000">
+              <a:srgbClr val="000000">
+                <a:alpha val="8000"/>
+              </a:srgbClr>
+            </a:outerShdw>
+          </a:effectLst>
+        </p:spPr>
+      </p:sp>
+      <p:sp>
+        <p:nvSpPr>
+          <p:cNvPr id="6" name="Text 3"/>
+          <p:cNvSpPr txBox="1"/>
+          <p:nvPr/>
+        </p:nvSpPr>
+        <p:spPr>
+          <a:xfrm>
+            <a:off x="713232" y="5184648"/>
+            <a:ext cx="10780776" cy="877824"/>
+          </a:xfrm>
+          <a:prstGeom prst="rect">
+            <a:avLst/>
+          </a:prstGeom>
+          <a:noFill/>
+          <a:ln/>
+        </p:spPr>
+        <p:txBody>
+          <a:bodyPr wrap="square" lIns="0" tIns="0" rIns="0" bIns="0" rtlCol="0" anchor="t"/>
+          <a:lstStyle/>
+          <a:p>
+            <a:pPr indent="0" marL="0">
+              <a:buNone/>
+            </a:pPr>
+            <a:r>
+              <a:rPr lang="en-US" sz="1600" b="1" dirty="0">
+                <a:solidFill>
+                  <a:srgbClr val="2D5B3F"/>
+                </a:solidFill>
+                <a:latin typeface="Calibri" pitchFamily="34" charset="0"/>
+                <a:ea typeface="Calibri" pitchFamily="34" charset="-122"/>
+                <a:cs typeface="Calibri" pitchFamily="34" charset="-120"/>
+              </a:rPr>
+              <a:t>Demo</a:t>
+            </a:r>
+            <a:endParaRPr lang="en-US" sz="1600" dirty="0"/>
+          </a:p>
+          <a:p>
+            <a:pPr indent="0" marL="0">
+              <a:spcBef>
+                <a:spcPts val="400"/>
+              </a:spcBef>
+              <a:buNone/>
+            </a:pPr>
+            <a:r>
+              <a:rPr lang="en-US" sz="1400" dirty="0">
+                <a:solidFill>
+                  <a:srgbClr val="253027"/>
+                </a:solidFill>
+                <a:latin typeface="Calibri" pitchFamily="34" charset="0"/>
+                <a:ea typeface="Calibri" pitchFamily="34" charset="-122"/>
+                <a:cs typeface="Calibri" pitchFamily="34" charset="-120"/>
+              </a:rPr>
+              <a:t>Your phone, our app: the result shows the weight, its range, and one light with one sentence. Try one photo with the marker sheet and one without.</a:t>
+            </a:r>
+            <a:endParaRPr lang="en-US" sz="1600" dirty="0"/>
+          </a:p>
+        </p:txBody>
+      </p:sp>
+      <p:sp>
+        <p:nvSpPr>
+          <p:cNvPr id="25" name="Slide Number Placeholder 0"/>
+          <p:cNvSpPr>
+            <a:spLocks noGrp="1"/>
+          </p:cNvSpPr>
+          <p:nvPr>
+            <p:ph type="sldNum" sz="quarter" idx="4294967295"/>
+          </p:nvPr>
+        </p:nvSpPr>
+        <p:spPr>
+          <a:xfrm>
+            <a:off x="11247120" y="6446520"/>
+            <a:ext cx="457200" cy="274320"/>
+          </a:xfrm>
+          <a:prstGeom prst="rect">
+            <a:avLst/>
+          </a:prstGeom>
+          <a:extLst>
+            <a:ext uri="{C572A759-6A51-4108-AA02-DFA0A04FC94B}">
+              <ma14:wrappingTextBoxFlag xmlns:ma14="http://schemas.microsoft.com/office/mac/drawingml/2011/main" val="0"/>
+            </a:ext>
+          </a:extLst>
+        </p:spPr>
+        <p:txBody>
+          <a:bodyPr/>
+          <a:lstStyle>
+            <a:lvl1pPr>
+              <a:defRPr sz="1000">
+                <a:solidFill>
+                  <a:srgbClr val="687063"/>
+                </a:solidFill>
+                <a:latin typeface="Calibri"/>
+                <a:ea typeface="Calibri"/>
+                <a:cs typeface="Calibri"/>
+              </a:defRPr>
+            </a:lvl1pPr>
+          </a:lstStyle>
+          <a:p>
+            <a:pPr algn="r"/>
+            <a:fld id="{F7021451-1387-4CA6-816F-3879F97B5CBC}" type="slidenum">
+              <a:rPr b="0" lang="en-US"/>
+              <a:t>15</a:t>
+            </a:fld>
+            <a:endParaRPr lang="en-US"/>
+          </a:p>
+        </p:txBody>
+      </p:sp>
+    </p:spTree>
+  </p:cSld>
+  <p:clrMapOvr>
+    <a:masterClrMapping/>
+  </p:clrMapOvr>
+</p:sld>
+</file>
+
+<file path=ppt/slides/slide16.xml><?xml version="1.0" encoding="utf-8"?>
+<p:sld xmlns:a="http://schemas.openxmlformats.org/drawingml/2006/main" xmlns:r="http://schemas.openxmlformats.org/officeDocument/2006/relationships" xmlns:p="http://schemas.openxmlformats.org/presentationml/2006/main">
+  <p:cSld name="Slide 16">
+    <p:spTree>
+      <p:nvGrpSpPr>
+        <p:cNvPr id="1" name=""/>
+        <p:cNvGrpSpPr/>
+        <p:nvPr/>
+      </p:nvGrpSpPr>
+      <p:grpSpPr>
+        <a:xfrm>
+          <a:off x="0" y="0"/>
+          <a:ext cx="0" cy="0"/>
+          <a:chOff x="0" y="0"/>
+          <a:chExt cx="0" cy="0"/>
+        </a:xfrm>
+      </p:grpSpPr>
+      <p:sp>
+        <p:nvSpPr>
+          <p:cNvPr id="2" name="Text 0"/>
+          <p:cNvSpPr txBox="1"/>
+          <p:nvPr/>
+        </p:nvSpPr>
+        <p:spPr>
+          <a:xfrm>
+            <a:off x="548640" y="320040"/>
+            <a:ext cx="9509760" cy="685800"/>
+          </a:xfrm>
+          <a:prstGeom prst="rect">
+            <a:avLst/>
+          </a:prstGeom>
+          <a:noFill/>
+          <a:ln/>
+        </p:spPr>
+        <p:txBody>
+          <a:bodyPr wrap="square" lIns="0" tIns="0" rIns="0" bIns="0" rtlCol="0" anchor="ctr"/>
+          <a:lstStyle/>
+          <a:p>
+            <a:pPr indent="0" marL="0">
+              <a:buNone/>
+            </a:pPr>
+            <a:r>
+              <a:rPr lang="en-US" sz="3000" b="1" dirty="0">
+                <a:solidFill>
+                  <a:srgbClr val="2D5B3F"/>
+                </a:solidFill>
+                <a:latin typeface="Cambria" pitchFamily="34" charset="0"/>
+                <a:ea typeface="Cambria" pitchFamily="34" charset="-122"/>
+                <a:cs typeface="Cambria" pitchFamily="34" charset="-120"/>
+              </a:rPr>
               <a:t>Sources and files</a:t>
             </a:r>
             <a:endParaRPr lang="en-US" sz="3000" dirty="0"/>
@@ -9469,7 +11513,7 @@
             <a:pPr algn="r"/>
             <a:fld id="{F7021451-1387-4CA6-816F-3879F97B5CBC}" type="slidenum">
               <a:rPr b="0" lang="en-US"/>
-              <a:t>15</a:t>
+              <a:t>16</a:t>
             </a:fld>
             <a:endParaRPr lang="en-US"/>
           </a:p>
@@ -9665,7 +11709,7 @@
                 <a:ea typeface="Calibri" pitchFamily="34" charset="-122"/>
                 <a:cs typeface="Calibri" pitchFamily="34" charset="-120"/>
               </a:rPr>
-              <a:t>We listed and measured 32 variables. Camera height, phone and person are removed by the fixed scale: each changes the count by less than 2 %.</a:t>
+              <a:t>We listed 32 variables and measured most of them (the untested ones are marked). Camera height, phone and person are removed by the fixed scale.</a:t>
             </a:r>
             <a:endParaRPr lang="en-US" sz="1600" dirty="0"/>
           </a:p>
@@ -9851,7 +11895,7 @@
                 <a:ea typeface="Calibri" pitchFamily="34" charset="-122"/>
                 <a:cs typeface="Calibri" pitchFamily="34" charset="-120"/>
               </a:rPr>
-              <a:t>10 piles (about 2 hours, about 100 euro) give ±9.4 %. We have 17 piles: ±8.7 %. More piles add almost nothing.</a:t>
+              <a:t>10 piles (about 2 hours, about 100 euro) give ±9.4 % with the marker sheet. We have 17 piles: ±8.7 %. Jia's 9 test piles: 9 of 9 inside.</a:t>
             </a:r>
             <a:endParaRPr lang="en-US" sz="1600" dirty="0"/>
           </a:p>
@@ -9890,7 +11934,7 @@
                 <a:ea typeface="Calibri" pitchFamily="34" charset="-122"/>
                 <a:cs typeface="Calibri" pitchFamily="34" charset="-120"/>
               </a:rPr>
-              <a:t>±8.7 %</a:t>
+              <a:t>1.2 %</a:t>
             </a:r>
             <a:endParaRPr lang="en-US" sz="4000" dirty="0"/>
           </a:p>
@@ -9907,7 +11951,7 @@
                 <a:ea typeface="Calibri" pitchFamily="34" charset="-122"/>
                 <a:cs typeface="Calibri" pitchFamily="34" charset="-120"/>
               </a:rPr>
-              <a:t>95 % range for one photo (17 piles, with the marker sheet)</a:t>
+              <a:t>what the photo itself adds: one pile, 16 photos, 2 persons, 2 phones, 2 heights</a:t>
             </a:r>
             <a:endParaRPr lang="en-US" sz="4000" dirty="0"/>
           </a:p>
@@ -9946,7 +11990,7 @@
                 <a:ea typeface="Calibri" pitchFamily="34" charset="-122"/>
                 <a:cs typeface="Calibri" pitchFamily="34" charset="-120"/>
               </a:rPr>
-              <a:t>9 of 9</a:t>
+              <a:t>53 of 53</a:t>
             </a:r>
             <a:endParaRPr lang="en-US" sz="4000" dirty="0"/>
           </a:p>
@@ -9963,7 +12007,7 @@
                 <a:ea typeface="Calibri" pitchFamily="34" charset="-122"/>
                 <a:cs typeface="Calibri" pitchFamily="34" charset="-120"/>
               </a:rPr>
-              <a:t>of Jia's piles inside the bounds made from Hadi's piles</a:t>
+              <a:t>of our normal photos get a green light; all 6 problem photos orange</a:t>
             </a:r>
             <a:endParaRPr lang="en-US" sz="4000" dirty="0"/>
           </a:p>
@@ -10002,7 +12046,7 @@
                 <a:ea typeface="Calibri" pitchFamily="34" charset="-122"/>
                 <a:cs typeface="Calibri" pitchFamily="34" charset="-120"/>
               </a:rPr>
-              <a:t>1.2 %</a:t>
+              <a:t>±8.7 %</a:t>
             </a:r>
             <a:endParaRPr lang="en-US" sz="4000" dirty="0"/>
           </a:p>
@@ -10019,7 +12063,7 @@
                 <a:ea typeface="Calibri" pitchFamily="34" charset="-122"/>
                 <a:cs typeface="Calibri" pitchFamily="34" charset="-120"/>
               </a:rPr>
-              <a:t>spread on one pile: 16 photos, 2 persons, 2 phones, 2 heights</a:t>
+              <a:t>95 % range for one photo, 17 piles, about 3.6 hours of work</a:t>
             </a:r>
             <a:endParaRPr lang="en-US" sz="4000" dirty="0"/>
           </a:p>
@@ -10748,7 +12792,7 @@
                 <a:ea typeface="Calibri" pitchFamily="34" charset="-122"/>
                 <a:cs typeface="Calibri" pitchFamily="34" charset="-120"/>
               </a:rPr>
-              <a:t>No seed touches another: touching seeds gave 16 to 19 % fewer seeds.</a:t>
+              <a:t>No seed touches another: touching seeds gave 16 to 19 % fewer seeds.</a:t>
             </a:r>
             <a:endParaRPr lang="en-US" sz="1600" dirty="0"/>
           </a:p>
@@ -12843,7 +14887,7 @@
                           <a:ea typeface="Calibri" pitchFamily="34" charset="-122"/>
                           <a:cs typeface="Calibri" pitchFamily="34" charset="-120"/>
                         </a:rPr>
-                        <a:t>12 MP: -18 %, 8 MP: -43 % without fixed scale; about 2 % with it</a:t>
+                        <a:t>12 MP: -18 %, 8 MP: -43 % without fixed scale; about 2 % with it</a:t>
                       </a:r>
                       <a:endParaRPr lang="en-US" sz="1300" dirty="0">
                         <a:latin typeface="Calibri" charset="0"/>
@@ -13049,7 +15093,7 @@
                           <a:ea typeface="Calibri" pitchFamily="34" charset="-122"/>
                           <a:cs typeface="Calibri" pitchFamily="34" charset="-120"/>
                         </a:rPr>
-                        <a:t>Same pile: 0.0 % and +0.3 %</a:t>
+                        <a:t>Same pile: 0.0 % and +0.3 %</a:t>
                       </a:r>
                       <a:endParaRPr lang="en-US" sz="1300" dirty="0">
                         <a:latin typeface="Calibri" charset="0"/>
@@ -13255,7 +15299,7 @@
                           <a:ea typeface="Calibri" pitchFamily="34" charset="-122"/>
                           <a:cs typeface="Calibri" pitchFamily="34" charset="-120"/>
                         </a:rPr>
-                        <a:t>16 to 19 % fewer seeds</a:t>
+                        <a:t>16 to 19 % fewer seeds</a:t>
                       </a:r>
                       <a:endParaRPr lang="en-US" sz="1300" dirty="0">
                         <a:latin typeface="Calibri" charset="0"/>
@@ -13461,7 +15505,7 @@
                           <a:ea typeface="Calibri" pitchFamily="34" charset="-122"/>
                           <a:cs typeface="Calibri" pitchFamily="34" charset="-120"/>
                         </a:rPr>
-                        <a:t>9.5 % tilt: only -2.2 %</a:t>
+                        <a:t>Markers 9.5 % different in size: count only -2.2 %</a:t>
                       </a:r>
                       <a:endParaRPr lang="en-US" sz="1300" dirty="0">
                         <a:latin typeface="Calibri" charset="0"/>
@@ -13529,7 +15573,7 @@
                           <a:ea typeface="Calibri" pitchFamily="34" charset="-122"/>
                           <a:cs typeface="Calibri" pitchFamily="34" charset="-120"/>
                         </a:rPr>
-                        <a:t>Orange light above 5 % (after counting)</a:t>
+                        <a:t>Orange light above 5 % (after counting)</a:t>
                       </a:r>
                       <a:endParaRPr lang="en-US" sz="1300" dirty="0">
                         <a:latin typeface="Calibri" charset="0"/>
@@ -13667,7 +15711,7 @@
                           <a:ea typeface="Calibri" pitchFamily="34" charset="-122"/>
                           <a:cs typeface="Calibri" pitchFamily="34" charset="-120"/>
                         </a:rPr>
-                        <a:t>-12.6 % without a scale</a:t>
+                        <a:t>-12.6 % without a scale</a:t>
                       </a:r>
                       <a:endParaRPr lang="en-US" sz="1300" dirty="0">
                         <a:latin typeface="Calibri" charset="0"/>
@@ -13735,7 +15779,7 @@
                           <a:ea typeface="Calibri" pitchFamily="34" charset="-122"/>
                           <a:cs typeface="Calibri" pitchFamily="34" charset="-120"/>
                         </a:rPr>
-                        <a:t>Seeds used as the ruler: +1.5 %</a:t>
+                        <a:t>Seeds used as the ruler: +1.5 % (orange light)</a:t>
                       </a:r>
                       <a:endParaRPr lang="en-US" sz="1300" dirty="0">
                         <a:latin typeface="Calibri" charset="0"/>
@@ -13873,7 +15917,7 @@
                           <a:ea typeface="Calibri" pitchFamily="34" charset="-122"/>
                           <a:cs typeface="Calibri" pitchFamily="34" charset="-120"/>
                         </a:rPr>
-                        <a:t>+5 to +28.5 % when all boxes are counted</a:t>
+                        <a:t>+5 to +28.5 % when all boxes are counted</a:t>
                       </a:r>
                       <a:endParaRPr lang="en-US" sz="1300" dirty="0">
                         <a:latin typeface="Calibri" charset="0"/>
@@ -14079,7 +16123,7 @@
                           <a:ea typeface="Calibri" pitchFamily="34" charset="-122"/>
                           <a:cs typeface="Calibri" pitchFamily="34" charset="-120"/>
                         </a:rPr>
-                        <a:t>-2.3 to +2.0 %: no effect shown</a:t>
+                        <a:t>-2.3 to +2.0 %: no effect shown</a:t>
                       </a:r>
                       <a:endParaRPr lang="en-US" sz="1300" dirty="0">
                         <a:latin typeface="Calibri" charset="0"/>
@@ -14285,7 +16329,7 @@
                           <a:ea typeface="Calibri" pitchFamily="34" charset="-122"/>
                           <a:cs typeface="Calibri" pitchFamily="34" charset="-120"/>
                         </a:rPr>
-                        <a:t>1.7 % (2.9 % at 10 g)</a:t>
+                        <a:t>1.7 % (2.9 % at 10 g)</a:t>
                       </a:r>
                       <a:endParaRPr lang="en-US" sz="1300" dirty="0">
                         <a:latin typeface="Calibri" charset="0"/>
@@ -14632,6 +16676,99 @@
             </a:avLst>
           </a:prstGeom>
           <a:solidFill>
+            <a:srgbClr val="FBE3D6"/>
+          </a:solidFill>
+          <a:ln w="9525">
+            <a:solidFill>
+              <a:srgbClr val="FBE3D6"/>
+            </a:solidFill>
+            <a:prstDash val="solid"/>
+          </a:ln>
+          <a:effectLst>
+            <a:outerShdw sx="100000" sy="100000" kx="0" ky="0" algn="bl" rotWithShape="0" blurRad="50800" dist="19050" dir="5400000">
+              <a:srgbClr val="000000">
+                <a:alpha val="8000"/>
+              </a:srgbClr>
+            </a:outerShdw>
+          </a:effectLst>
+        </p:spPr>
+      </p:sp>
+      <p:sp>
+        <p:nvSpPr>
+          <p:cNvPr id="6" name="Text 3"/>
+          <p:cNvSpPr txBox="1"/>
+          <p:nvPr/>
+        </p:nvSpPr>
+        <p:spPr>
+          <a:xfrm>
+            <a:off x="7936992" y="1344168"/>
+            <a:ext cx="3557016" cy="1929384"/>
+          </a:xfrm>
+          <a:prstGeom prst="rect">
+            <a:avLst/>
+          </a:prstGeom>
+          <a:noFill/>
+          <a:ln/>
+        </p:spPr>
+        <p:txBody>
+          <a:bodyPr wrap="square" lIns="0" tIns="0" rIns="0" bIns="0" rtlCol="0" anchor="t"/>
+          <a:lstStyle/>
+          <a:p>
+            <a:pPr indent="0" marL="0">
+              <a:buNone/>
+            </a:pPr>
+            <a:r>
+              <a:rPr lang="en-US" sz="1600" b="1" dirty="0">
+                <a:solidFill>
+                  <a:srgbClr val="2D5B3F"/>
+                </a:solidFill>
+                <a:latin typeface="Calibri" pitchFamily="34" charset="0"/>
+                <a:ea typeface="Calibri" pitchFamily="34" charset="-122"/>
+                <a:cs typeface="Calibri" pitchFamily="34" charset="-120"/>
+              </a:rPr>
+              <a:t>Without the fixed scale</a:t>
+            </a:r>
+            <a:endParaRPr lang="en-US" sz="1600" dirty="0"/>
+          </a:p>
+          <a:p>
+            <a:pPr indent="0" marL="0">
+              <a:spcBef>
+                <a:spcPts val="400"/>
+              </a:spcBef>
+              <a:buNone/>
+            </a:pPr>
+            <a:r>
+              <a:rPr lang="en-US" sz="1400" dirty="0">
+                <a:solidFill>
+                  <a:srgbClr val="253027"/>
+                </a:solidFill>
+                <a:latin typeface="Calibri" pitchFamily="34" charset="0"/>
+                <a:ea typeface="Calibri" pitchFamily="34" charset="-122"/>
+                <a:cs typeface="Calibri" pitchFamily="34" charset="-120"/>
+              </a:rPr>
+              <a:t>112 to 292 seeds on the same pile (spread 18.6 %). A higher photo or a phone with fewer pixels makes seeds smaller, and the detector misses them.</a:t>
+            </a:r>
+            <a:endParaRPr lang="en-US" sz="1600" dirty="0"/>
+          </a:p>
+        </p:txBody>
+      </p:sp>
+      <p:sp>
+        <p:nvSpPr>
+          <p:cNvPr id="7" name="Shape 4"/>
+          <p:cNvSpPr/>
+          <p:nvPr/>
+        </p:nvSpPr>
+        <p:spPr>
+          <a:xfrm>
+            <a:off x="7772400" y="3566160"/>
+            <a:ext cx="3886200" cy="2606040"/>
+          </a:xfrm>
+          <a:prstGeom prst="roundRect">
+            <a:avLst>
+              <a:gd name="adj" fmla="val 4211"/>
+            </a:avLst>
+          </a:prstGeom>
+          <a:solidFill>
             <a:srgbClr val="E2ECDB"/>
           </a:solidFill>
           <a:ln w="9525">
@@ -14651,14 +16788,14 @@
       </p:sp>
       <p:sp>
         <p:nvSpPr>
-          <p:cNvPr id="6" name="Text 3"/>
+          <p:cNvPr id="8" name="Text 5"/>
           <p:cNvSpPr txBox="1"/>
           <p:nvPr/>
         </p:nvSpPr>
         <p:spPr>
           <a:xfrm>
-            <a:off x="7936992" y="1344168"/>
-            <a:ext cx="3557016" cy="1929384"/>
+            <a:off x="7936992" y="3675888"/>
+            <a:ext cx="3557016" cy="2386584"/>
           </a:xfrm>
           <a:prstGeom prst="rect">
             <a:avLst/>
@@ -14682,7 +16819,7 @@
                 <a:ea typeface="Calibri" pitchFamily="34" charset="-122"/>
                 <a:cs typeface="Calibri" pitchFamily="34" charset="-120"/>
               </a:rPr>
-              <a:t>Without the fixed scale</a:t>
+              <a:t>With the fixed scale</a:t>
             </a:r>
             <a:endParaRPr lang="en-US" sz="1600" dirty="0"/>
           </a:p>
@@ -14702,100 +16839,7 @@
                 <a:ea typeface="Calibri" pitchFamily="34" charset="-122"/>
                 <a:cs typeface="Calibri" pitchFamily="34" charset="-120"/>
               </a:rPr>
-              <a:t>112 to 292 seeds on the same pile (spread 18.6 %). A higher photo or a phone with fewer pixels makes seeds smaller, and the detector misses them.</a:t>
-            </a:r>
-            <a:endParaRPr lang="en-US" sz="1600" dirty="0"/>
-          </a:p>
-        </p:txBody>
-      </p:sp>
-      <p:sp>
-        <p:nvSpPr>
-          <p:cNvPr id="7" name="Shape 4"/>
-          <p:cNvSpPr/>
-          <p:nvPr/>
-        </p:nvSpPr>
-        <p:spPr>
-          <a:xfrm>
-            <a:off x="7772400" y="3566160"/>
-            <a:ext cx="3886200" cy="2606040"/>
-          </a:xfrm>
-          <a:prstGeom prst="roundRect">
-            <a:avLst>
-              <a:gd name="adj" fmla="val 4211"/>
-            </a:avLst>
-          </a:prstGeom>
-          <a:solidFill>
-            <a:srgbClr val="FFF1BE"/>
-          </a:solidFill>
-          <a:ln w="9525">
-            <a:solidFill>
-              <a:srgbClr val="FFF1BE"/>
-            </a:solidFill>
-            <a:prstDash val="solid"/>
-          </a:ln>
-          <a:effectLst>
-            <a:outerShdw sx="100000" sy="100000" kx="0" ky="0" algn="bl" rotWithShape="0" blurRad="50800" dist="19050" dir="5400000">
-              <a:srgbClr val="000000">
-                <a:alpha val="8000"/>
-              </a:srgbClr>
-            </a:outerShdw>
-          </a:effectLst>
-        </p:spPr>
-      </p:sp>
-      <p:sp>
-        <p:nvSpPr>
-          <p:cNvPr id="8" name="Text 5"/>
-          <p:cNvSpPr txBox="1"/>
-          <p:nvPr/>
-        </p:nvSpPr>
-        <p:spPr>
-          <a:xfrm>
-            <a:off x="7936992" y="3675888"/>
-            <a:ext cx="3557016" cy="2386584"/>
-          </a:xfrm>
-          <a:prstGeom prst="rect">
-            <a:avLst/>
-          </a:prstGeom>
-          <a:noFill/>
-          <a:ln/>
-        </p:spPr>
-        <p:txBody>
-          <a:bodyPr wrap="square" lIns="0" tIns="0" rIns="0" bIns="0" rtlCol="0" anchor="t"/>
-          <a:lstStyle/>
-          <a:p>
-            <a:pPr indent="0" marL="0">
-              <a:buNone/>
-            </a:pPr>
-            <a:r>
-              <a:rPr lang="en-US" sz="1600" b="1" dirty="0">
-                <a:solidFill>
-                  <a:srgbClr val="2D5B3F"/>
-                </a:solidFill>
-                <a:latin typeface="Calibri" pitchFamily="34" charset="0"/>
-                <a:ea typeface="Calibri" pitchFamily="34" charset="-122"/>
-                <a:cs typeface="Calibri" pitchFamily="34" charset="-120"/>
-              </a:rPr>
-              <a:t>With the fixed scale</a:t>
-            </a:r>
-            <a:endParaRPr lang="en-US" sz="1600" dirty="0"/>
-          </a:p>
-          <a:p>
-            <a:pPr indent="0" marL="0">
-              <a:spcBef>
-                <a:spcPts val="400"/>
-              </a:spcBef>
-              <a:buNone/>
-            </a:pPr>
-            <a:r>
-              <a:rPr lang="en-US" sz="1400" dirty="0">
-                <a:solidFill>
-                  <a:srgbClr val="253027"/>
-                </a:solidFill>
-                <a:latin typeface="Calibri" pitchFamily="34" charset="0"/>
-                <a:ea typeface="Calibri" pitchFamily="34" charset="-122"/>
-                <a:cs typeface="Calibri" pitchFamily="34" charset="-120"/>
-              </a:rPr>
-              <a:t>283 to 298 seeds (spread 1.2 %). The two 50 mm markers give mm per pixel; every photo is resized to 0.110 mm per pixel before counting. Built into the app.</a:t>
+              <a:t>283 to 298 seeds (spread 1.2 %). The two 50 mm markers give mm per pixel; every photo is resized to 0.110 mm per pixel before counting. Built into the app.</a:t>
             </a:r>
             <a:endParaRPr lang="en-US" sz="1600" dirty="0"/>
           </a:p>
@@ -15097,7 +17141,7 @@
                 <a:ea typeface="Calibri" pitchFamily="34" charset="-122"/>
                 <a:cs typeface="Calibri" pitchFamily="34" charset="-120"/>
               </a:rPr>
-              <a:t>0.0 %</a:t>
+              <a:t>0.0 %</a:t>
             </a:r>
             <a:endParaRPr lang="en-US" sz="3600" dirty="0"/>
           </a:p>
@@ -15136,7 +17180,7 @@
                 <a:ea typeface="Calibri" pitchFamily="34" charset="-122"/>
                 <a:cs typeface="Calibri" pitchFamily="34" charset="-120"/>
               </a:rPr>
-              <a:t>Jia minus Hadi; 95 % CI -1.4 to +1.5 %</a:t>
+              <a:t>Jia minus Hadi; 95 % CI -1.4 to +1.5 %</a:t>
             </a:r>
             <a:endParaRPr lang="en-US" sz="1300" dirty="0"/>
           </a:p>
@@ -15248,7 +17292,7 @@
                 <a:ea typeface="Calibri" pitchFamily="34" charset="-122"/>
                 <a:cs typeface="Calibri" pitchFamily="34" charset="-120"/>
               </a:rPr>
-              <a:t>+0.3 %</a:t>
+              <a:t>+0.3 %</a:t>
             </a:r>
             <a:endParaRPr lang="en-US" sz="3600" dirty="0"/>
           </a:p>
@@ -15287,7 +17331,7 @@
                 <a:ea typeface="Calibri" pitchFamily="34" charset="-122"/>
                 <a:cs typeface="Calibri" pitchFamily="34" charset="-120"/>
               </a:rPr>
-              <a:t>iPhone 14 minus iPhone 15 Pro; CI -1.1 to +1.7 %</a:t>
+              <a:t>iPhone 14 minus iPhone 15 Pro; CI -1.1 to +1.7 %</a:t>
             </a:r>
             <a:endParaRPr lang="en-US" sz="1300" dirty="0"/>
           </a:p>
@@ -15399,7 +17443,7 @@
                 <a:ea typeface="Calibri" pitchFamily="34" charset="-122"/>
                 <a:cs typeface="Calibri" pitchFamily="34" charset="-120"/>
               </a:rPr>
-              <a:t>0.0 %</a:t>
+              <a:t>0.0 %</a:t>
             </a:r>
             <a:endParaRPr lang="en-US" sz="3600" dirty="0"/>
           </a:p>
@@ -15438,7 +17482,7 @@
                 <a:ea typeface="Calibri" pitchFamily="34" charset="-122"/>
                 <a:cs typeface="Calibri" pitchFamily="34" charset="-120"/>
               </a:rPr>
-              <a:t>high minus normal; CI -1.3 to +1.3 %</a:t>
+              <a:t>high minus normal; CI -1.3 to +1.3 %</a:t>
             </a:r>
             <a:endParaRPr lang="en-US" sz="1300" dirty="0"/>
           </a:p>
@@ -15550,7 +17594,7 @@
                 <a:ea typeface="Calibri" pitchFamily="34" charset="-122"/>
                 <a:cs typeface="Calibri" pitchFamily="34" charset="-120"/>
               </a:rPr>
-              <a:t>1.3 %</a:t>
+              <a:t>1.3 %</a:t>
             </a:r>
             <a:endParaRPr lang="en-US" sz="3600" dirty="0"/>
           </a:p>
@@ -15682,7 +17726,7 @@
                 <a:ea typeface="Calibri" pitchFamily="34" charset="-122"/>
                 <a:cs typeface="Calibri" pitchFamily="34" charset="-120"/>
               </a:rPr>
-              <a:t>The 8 groups (person x phone x height) differ no more than two photos in the same group (analysis of variance, p = 0.81). The photo adds about 1 %; piles differ by about 4 %.</a:t>
+              <a:t>The 8 groups (person x phone x height) differ no more than two photos in the same group (analysis of variance, p = 0.81). The photo adds about 1 %; piles differ by about 4 %.</a:t>
             </a:r>
             <a:endParaRPr lang="en-US" sz="1600" dirty="0"/>
           </a:p>
@@ -15955,9 +17999,10 @@
             <a:tbl>
               <a:tblPr/>
               <a:tblGrid>
-                <a:gridCol w="3840480"/>
-                <a:gridCol w="1463040"/>
-                <a:gridCol w="1463040"/>
+                <a:gridCol w="3017520"/>
+                <a:gridCol w="822960"/>
+                <a:gridCol w="1737360"/>
+                <a:gridCol w="1188720"/>
               </a:tblGrid>
               <a:tr h="457200">
                 <a:tc>
@@ -16045,7 +18090,75 @@
                           <a:ea typeface="Calibri" pitchFamily="34" charset="-122"/>
                           <a:cs typeface="Calibri" pitchFamily="34" charset="-120"/>
                         </a:rPr>
-                        <a:t>Correlation r</a:t>
+                        <a:t>r</a:t>
+                      </a:r>
+                      <a:endParaRPr lang="en-US" sz="1400" dirty="0">
+                        <a:latin typeface="Calibri" charset="0"/>
+                        <a:ea typeface="Calibri" charset="0"/>
+                        <a:cs typeface="Calibri" charset="0"/>
+                      </a:endParaRPr>
+                    </a:p>
+                  </a:txBody>
+                  <a:tcPr marL="91440" marR="91440" marT="45720" marB="45720">
+                    <a:lnL w="9525" cap="flat" cmpd="sng" algn="ctr">
+                      <a:solidFill>
+                        <a:srgbClr val="E6E1D3"/>
+                      </a:solidFill>
+                      <a:prstDash val="solid"/>
+                      <a:round/>
+                      <a:headEnd type="none" w="med" len="med"/>
+                      <a:tailEnd type="none" w="med" len="med"/>
+                    </a:lnL>
+                    <a:lnR w="9525" cap="flat" cmpd="sng" algn="ctr">
+                      <a:solidFill>
+                        <a:srgbClr val="E6E1D3"/>
+                      </a:solidFill>
+                      <a:prstDash val="solid"/>
+                      <a:round/>
+                      <a:headEnd type="none" w="med" len="med"/>
+                      <a:tailEnd type="none" w="med" len="med"/>
+                    </a:lnR>
+                    <a:lnT w="9525" cap="flat" cmpd="sng" algn="ctr">
+                      <a:solidFill>
+                        <a:srgbClr val="E6E1D3"/>
+                      </a:solidFill>
+                      <a:prstDash val="solid"/>
+                      <a:round/>
+                      <a:headEnd type="none" w="med" len="med"/>
+                      <a:tailEnd type="none" w="med" len="med"/>
+                    </a:lnT>
+                    <a:lnB w="9525" cap="flat" cmpd="sng" algn="ctr">
+                      <a:solidFill>
+                        <a:srgbClr val="E6E1D3"/>
+                      </a:solidFill>
+                      <a:prstDash val="solid"/>
+                      <a:round/>
+                      <a:headEnd type="none" w="med" len="med"/>
+                      <a:tailEnd type="none" w="med" len="med"/>
+                    </a:lnB>
+                    <a:solidFill>
+                      <a:srgbClr val="2D5B3F"/>
+                    </a:solidFill>
+                  </a:tcPr>
+                </a:tc>
+                <a:tc>
+                  <a:txBody>
+                    <a:bodyPr/>
+                    <a:lstStyle/>
+                    <a:p>
+                      <a:pPr indent="0" marL="0">
+                        <a:buNone/>
+                      </a:pPr>
+                      <a:r>
+                        <a:rPr lang="en-US" sz="1400" b="1" dirty="0">
+                          <a:solidFill>
+                            <a:srgbClr val="FFFFFF"/>
+                          </a:solidFill>
+                          <a:latin typeface="Calibri" pitchFamily="34" charset="0"/>
+                          <a:ea typeface="Calibri" pitchFamily="34" charset="-122"/>
+                          <a:cs typeface="Calibri" pitchFamily="34" charset="-120"/>
+                        </a:rPr>
+                        <a:t>95 % range of r</a:t>
                       </a:r>
                       <a:endParaRPr lang="en-US" sz="1400" dirty="0">
                         <a:latin typeface="Calibri" charset="0"/>
@@ -16319,7 +18432,75 @@
                           <a:ea typeface="Calibri" pitchFamily="34" charset="-122"/>
                           <a:cs typeface="Calibri" pitchFamily="34" charset="-120"/>
                         </a:rPr>
-                        <a:t>3.7 %</a:t>
+                        <a:t>0.950 to 0.999</a:t>
+                      </a:r>
+                      <a:endParaRPr lang="en-US" sz="1400" dirty="0">
+                        <a:latin typeface="Calibri" charset="0"/>
+                        <a:ea typeface="Calibri" charset="0"/>
+                        <a:cs typeface="Calibri" charset="0"/>
+                      </a:endParaRPr>
+                    </a:p>
+                  </a:txBody>
+                  <a:tcPr marL="91440" marR="91440" marT="45720" marB="45720">
+                    <a:lnL w="9525" cap="flat" cmpd="sng" algn="ctr">
+                      <a:solidFill>
+                        <a:srgbClr val="E6E1D3"/>
+                      </a:solidFill>
+                      <a:prstDash val="solid"/>
+                      <a:round/>
+                      <a:headEnd type="none" w="med" len="med"/>
+                      <a:tailEnd type="none" w="med" len="med"/>
+                    </a:lnL>
+                    <a:lnR w="9525" cap="flat" cmpd="sng" algn="ctr">
+                      <a:solidFill>
+                        <a:srgbClr val="E6E1D3"/>
+                      </a:solidFill>
+                      <a:prstDash val="solid"/>
+                      <a:round/>
+                      <a:headEnd type="none" w="med" len="med"/>
+                      <a:tailEnd type="none" w="med" len="med"/>
+                    </a:lnR>
+                    <a:lnT w="9525" cap="flat" cmpd="sng" algn="ctr">
+                      <a:solidFill>
+                        <a:srgbClr val="E6E1D3"/>
+                      </a:solidFill>
+                      <a:prstDash val="solid"/>
+                      <a:round/>
+                      <a:headEnd type="none" w="med" len="med"/>
+                      <a:tailEnd type="none" w="med" len="med"/>
+                    </a:lnT>
+                    <a:lnB w="9525" cap="flat" cmpd="sng" algn="ctr">
+                      <a:solidFill>
+                        <a:srgbClr val="E6E1D3"/>
+                      </a:solidFill>
+                      <a:prstDash val="solid"/>
+                      <a:round/>
+                      <a:headEnd type="none" w="med" len="med"/>
+                      <a:tailEnd type="none" w="med" len="med"/>
+                    </a:lnB>
+                    <a:solidFill>
+                      <a:srgbClr val="FFFFFF"/>
+                    </a:solidFill>
+                  </a:tcPr>
+                </a:tc>
+                <a:tc>
+                  <a:txBody>
+                    <a:bodyPr/>
+                    <a:lstStyle/>
+                    <a:p>
+                      <a:pPr indent="0" marL="0">
+                        <a:buNone/>
+                      </a:pPr>
+                      <a:r>
+                        <a:rPr lang="en-US" sz="1400" dirty="0">
+                          <a:solidFill>
+                            <a:srgbClr val="253027"/>
+                          </a:solidFill>
+                          <a:latin typeface="Calibri" pitchFamily="34" charset="0"/>
+                          <a:ea typeface="Calibri" pitchFamily="34" charset="-122"/>
+                          <a:cs typeface="Calibri" pitchFamily="34" charset="-120"/>
+                        </a:rPr>
+                        <a:t>3.7 %</a:t>
                       </a:r>
                       <a:endParaRPr lang="en-US" sz="1400" dirty="0">
                         <a:latin typeface="Calibri" charset="0"/>
@@ -16525,7 +18706,75 @@
                           <a:ea typeface="Calibri" pitchFamily="34" charset="-122"/>
                           <a:cs typeface="Calibri" pitchFamily="34" charset="-120"/>
                         </a:rPr>
-                        <a:t>4.0 %</a:t>
+                        <a:t>0.945 to 0.999</a:t>
+                      </a:r>
+                      <a:endParaRPr lang="en-US" sz="1400" dirty="0">
+                        <a:latin typeface="Calibri" charset="0"/>
+                        <a:ea typeface="Calibri" charset="0"/>
+                        <a:cs typeface="Calibri" charset="0"/>
+                      </a:endParaRPr>
+                    </a:p>
+                  </a:txBody>
+                  <a:tcPr marL="91440" marR="91440" marT="45720" marB="45720">
+                    <a:lnL w="9525" cap="flat" cmpd="sng" algn="ctr">
+                      <a:solidFill>
+                        <a:srgbClr val="E6E1D3"/>
+                      </a:solidFill>
+                      <a:prstDash val="solid"/>
+                      <a:round/>
+                      <a:headEnd type="none" w="med" len="med"/>
+                      <a:tailEnd type="none" w="med" len="med"/>
+                    </a:lnL>
+                    <a:lnR w="9525" cap="flat" cmpd="sng" algn="ctr">
+                      <a:solidFill>
+                        <a:srgbClr val="E6E1D3"/>
+                      </a:solidFill>
+                      <a:prstDash val="solid"/>
+                      <a:round/>
+                      <a:headEnd type="none" w="med" len="med"/>
+                      <a:tailEnd type="none" w="med" len="med"/>
+                    </a:lnR>
+                    <a:lnT w="9525" cap="flat" cmpd="sng" algn="ctr">
+                      <a:solidFill>
+                        <a:srgbClr val="E6E1D3"/>
+                      </a:solidFill>
+                      <a:prstDash val="solid"/>
+                      <a:round/>
+                      <a:headEnd type="none" w="med" len="med"/>
+                      <a:tailEnd type="none" w="med" len="med"/>
+                    </a:lnT>
+                    <a:lnB w="9525" cap="flat" cmpd="sng" algn="ctr">
+                      <a:solidFill>
+                        <a:srgbClr val="E6E1D3"/>
+                      </a:solidFill>
+                      <a:prstDash val="solid"/>
+                      <a:round/>
+                      <a:headEnd type="none" w="med" len="med"/>
+                      <a:tailEnd type="none" w="med" len="med"/>
+                    </a:lnB>
+                    <a:solidFill>
+                      <a:srgbClr val="FFF1BE"/>
+                    </a:solidFill>
+                  </a:tcPr>
+                </a:tc>
+                <a:tc>
+                  <a:txBody>
+                    <a:bodyPr/>
+                    <a:lstStyle/>
+                    <a:p>
+                      <a:pPr indent="0" marL="0">
+                        <a:buNone/>
+                      </a:pPr>
+                      <a:r>
+                        <a:rPr lang="en-US" sz="1400" b="1" dirty="0">
+                          <a:solidFill>
+                            <a:srgbClr val="253027"/>
+                          </a:solidFill>
+                          <a:latin typeface="Calibri" pitchFamily="34" charset="0"/>
+                          <a:ea typeface="Calibri" pitchFamily="34" charset="-122"/>
+                          <a:cs typeface="Calibri" pitchFamily="34" charset="-120"/>
+                        </a:rPr>
+                        <a:t>4.0 %</a:t>
                       </a:r>
                       <a:endParaRPr lang="en-US" sz="1400" dirty="0">
                         <a:latin typeface="Calibri" charset="0"/>
@@ -16595,7 +18844,7 @@
                           <a:ea typeface="Calibri" pitchFamily="34" charset="-122"/>
                           <a:cs typeface="Calibri" pitchFamily="34" charset="-120"/>
                         </a:rPr>
-                        <a:t>Box area of sunflower boxes, mm2</a:t>
+                        <a:t>Box area of sunflower boxes, mm²</a:t>
                       </a:r>
                       <a:endParaRPr lang="en-US" sz="1400" dirty="0">
                         <a:latin typeface="Calibri" charset="0"/>
@@ -16731,7 +18980,75 @@
                           <a:ea typeface="Calibri" pitchFamily="34" charset="-122"/>
                           <a:cs typeface="Calibri" pitchFamily="34" charset="-120"/>
                         </a:rPr>
-                        <a:t>5.4 %</a:t>
+                        <a:t>0.930 to 0.999</a:t>
+                      </a:r>
+                      <a:endParaRPr lang="en-US" sz="1400" dirty="0">
+                        <a:latin typeface="Calibri" charset="0"/>
+                        <a:ea typeface="Calibri" charset="0"/>
+                        <a:cs typeface="Calibri" charset="0"/>
+                      </a:endParaRPr>
+                    </a:p>
+                  </a:txBody>
+                  <a:tcPr marL="91440" marR="91440" marT="45720" marB="45720">
+                    <a:lnL w="9525" cap="flat" cmpd="sng" algn="ctr">
+                      <a:solidFill>
+                        <a:srgbClr val="E6E1D3"/>
+                      </a:solidFill>
+                      <a:prstDash val="solid"/>
+                      <a:round/>
+                      <a:headEnd type="none" w="med" len="med"/>
+                      <a:tailEnd type="none" w="med" len="med"/>
+                    </a:lnL>
+                    <a:lnR w="9525" cap="flat" cmpd="sng" algn="ctr">
+                      <a:solidFill>
+                        <a:srgbClr val="E6E1D3"/>
+                      </a:solidFill>
+                      <a:prstDash val="solid"/>
+                      <a:round/>
+                      <a:headEnd type="none" w="med" len="med"/>
+                      <a:tailEnd type="none" w="med" len="med"/>
+                    </a:lnR>
+                    <a:lnT w="9525" cap="flat" cmpd="sng" algn="ctr">
+                      <a:solidFill>
+                        <a:srgbClr val="E6E1D3"/>
+                      </a:solidFill>
+                      <a:prstDash val="solid"/>
+                      <a:round/>
+                      <a:headEnd type="none" w="med" len="med"/>
+                      <a:tailEnd type="none" w="med" len="med"/>
+                    </a:lnT>
+                    <a:lnB w="9525" cap="flat" cmpd="sng" algn="ctr">
+                      <a:solidFill>
+                        <a:srgbClr val="E6E1D3"/>
+                      </a:solidFill>
+                      <a:prstDash val="solid"/>
+                      <a:round/>
+                      <a:headEnd type="none" w="med" len="med"/>
+                      <a:tailEnd type="none" w="med" len="med"/>
+                    </a:lnB>
+                    <a:solidFill>
+                      <a:srgbClr val="FFFFFF"/>
+                    </a:solidFill>
+                  </a:tcPr>
+                </a:tc>
+                <a:tc>
+                  <a:txBody>
+                    <a:bodyPr/>
+                    <a:lstStyle/>
+                    <a:p>
+                      <a:pPr indent="0" marL="0">
+                        <a:buNone/>
+                      </a:pPr>
+                      <a:r>
+                        <a:rPr lang="en-US" sz="1400" dirty="0">
+                          <a:solidFill>
+                            <a:srgbClr val="253027"/>
+                          </a:solidFill>
+                          <a:latin typeface="Calibri" pitchFamily="34" charset="0"/>
+                          <a:ea typeface="Calibri" pitchFamily="34" charset="-122"/>
+                          <a:cs typeface="Calibri" pitchFamily="34" charset="-120"/>
+                        </a:rPr>
+                        <a:t>5.4 %</a:t>
                       </a:r>
                       <a:endParaRPr lang="en-US" sz="1400" dirty="0">
                         <a:latin typeface="Calibri" charset="0"/>
@@ -16937,7 +19254,75 @@
                           <a:ea typeface="Calibri" pitchFamily="34" charset="-122"/>
                           <a:cs typeface="Calibri" pitchFamily="34" charset="-120"/>
                         </a:rPr>
-                        <a:t>11.6 %</a:t>
+                        <a:t>0.635 to 0.990</a:t>
+                      </a:r>
+                      <a:endParaRPr lang="en-US" sz="1400" dirty="0">
+                        <a:latin typeface="Calibri" charset="0"/>
+                        <a:ea typeface="Calibri" charset="0"/>
+                        <a:cs typeface="Calibri" charset="0"/>
+                      </a:endParaRPr>
+                    </a:p>
+                  </a:txBody>
+                  <a:tcPr marL="91440" marR="91440" marT="45720" marB="45720">
+                    <a:lnL w="9525" cap="flat" cmpd="sng" algn="ctr">
+                      <a:solidFill>
+                        <a:srgbClr val="E6E1D3"/>
+                      </a:solidFill>
+                      <a:prstDash val="solid"/>
+                      <a:round/>
+                      <a:headEnd type="none" w="med" len="med"/>
+                      <a:tailEnd type="none" w="med" len="med"/>
+                    </a:lnL>
+                    <a:lnR w="9525" cap="flat" cmpd="sng" algn="ctr">
+                      <a:solidFill>
+                        <a:srgbClr val="E6E1D3"/>
+                      </a:solidFill>
+                      <a:prstDash val="solid"/>
+                      <a:round/>
+                      <a:headEnd type="none" w="med" len="med"/>
+                      <a:tailEnd type="none" w="med" len="med"/>
+                    </a:lnR>
+                    <a:lnT w="9525" cap="flat" cmpd="sng" algn="ctr">
+                      <a:solidFill>
+                        <a:srgbClr val="E6E1D3"/>
+                      </a:solidFill>
+                      <a:prstDash val="solid"/>
+                      <a:round/>
+                      <a:headEnd type="none" w="med" len="med"/>
+                      <a:tailEnd type="none" w="med" len="med"/>
+                    </a:lnT>
+                    <a:lnB w="9525" cap="flat" cmpd="sng" algn="ctr">
+                      <a:solidFill>
+                        <a:srgbClr val="E6E1D3"/>
+                      </a:solidFill>
+                      <a:prstDash val="solid"/>
+                      <a:round/>
+                      <a:headEnd type="none" w="med" len="med"/>
+                      <a:tailEnd type="none" w="med" len="med"/>
+                    </a:lnB>
+                    <a:solidFill>
+                      <a:srgbClr val="FFFFFF"/>
+                    </a:solidFill>
+                  </a:tcPr>
+                </a:tc>
+                <a:tc>
+                  <a:txBody>
+                    <a:bodyPr/>
+                    <a:lstStyle/>
+                    <a:p>
+                      <a:pPr indent="0" marL="0">
+                        <a:buNone/>
+                      </a:pPr>
+                      <a:r>
+                        <a:rPr lang="en-US" sz="1400" dirty="0">
+                          <a:solidFill>
+                            <a:srgbClr val="253027"/>
+                          </a:solidFill>
+                          <a:latin typeface="Calibri" pitchFamily="34" charset="0"/>
+                          <a:ea typeface="Calibri" pitchFamily="34" charset="-122"/>
+                          <a:cs typeface="Calibri" pitchFamily="34" charset="-120"/>
+                        </a:rPr>
+                        <a:t>11.6 %</a:t>
                       </a:r>
                       <a:endParaRPr lang="en-US" sz="1400" dirty="0">
                         <a:latin typeface="Calibri" charset="0"/>
@@ -17143,7 +19528,75 @@
                           <a:ea typeface="Calibri" pitchFamily="34" charset="-122"/>
                           <a:cs typeface="Calibri" pitchFamily="34" charset="-120"/>
                         </a:rPr>
-                        <a:t>35.7 %</a:t>
+                        <a:t>-0.984 to 0.753</a:t>
+                      </a:r>
+                      <a:endParaRPr lang="en-US" sz="1400" dirty="0">
+                        <a:latin typeface="Calibri" charset="0"/>
+                        <a:ea typeface="Calibri" charset="0"/>
+                        <a:cs typeface="Calibri" charset="0"/>
+                      </a:endParaRPr>
+                    </a:p>
+                  </a:txBody>
+                  <a:tcPr marL="91440" marR="91440" marT="45720" marB="45720">
+                    <a:lnL w="9525" cap="flat" cmpd="sng" algn="ctr">
+                      <a:solidFill>
+                        <a:srgbClr val="E6E1D3"/>
+                      </a:solidFill>
+                      <a:prstDash val="solid"/>
+                      <a:round/>
+                      <a:headEnd type="none" w="med" len="med"/>
+                      <a:tailEnd type="none" w="med" len="med"/>
+                    </a:lnL>
+                    <a:lnR w="9525" cap="flat" cmpd="sng" algn="ctr">
+                      <a:solidFill>
+                        <a:srgbClr val="E6E1D3"/>
+                      </a:solidFill>
+                      <a:prstDash val="solid"/>
+                      <a:round/>
+                      <a:headEnd type="none" w="med" len="med"/>
+                      <a:tailEnd type="none" w="med" len="med"/>
+                    </a:lnR>
+                    <a:lnT w="9525" cap="flat" cmpd="sng" algn="ctr">
+                      <a:solidFill>
+                        <a:srgbClr val="E6E1D3"/>
+                      </a:solidFill>
+                      <a:prstDash val="solid"/>
+                      <a:round/>
+                      <a:headEnd type="none" w="med" len="med"/>
+                      <a:tailEnd type="none" w="med" len="med"/>
+                    </a:lnT>
+                    <a:lnB w="9525" cap="flat" cmpd="sng" algn="ctr">
+                      <a:solidFill>
+                        <a:srgbClr val="E6E1D3"/>
+                      </a:solidFill>
+                      <a:prstDash val="solid"/>
+                      <a:round/>
+                      <a:headEnd type="none" w="med" len="med"/>
+                      <a:tailEnd type="none" w="med" len="med"/>
+                    </a:lnB>
+                    <a:solidFill>
+                      <a:srgbClr val="FFFFFF"/>
+                    </a:solidFill>
+                  </a:tcPr>
+                </a:tc>
+                <a:tc>
+                  <a:txBody>
+                    <a:bodyPr/>
+                    <a:lstStyle/>
+                    <a:p>
+                      <a:pPr indent="0" marL="0">
+                        <a:buNone/>
+                      </a:pPr>
+                      <a:r>
+                        <a:rPr lang="en-US" sz="1400" dirty="0">
+                          <a:solidFill>
+                            <a:srgbClr val="253027"/>
+                          </a:solidFill>
+                          <a:latin typeface="Calibri" pitchFamily="34" charset="0"/>
+                          <a:ea typeface="Calibri" pitchFamily="34" charset="-122"/>
+                          <a:cs typeface="Calibri" pitchFamily="34" charset="-120"/>
+                        </a:rPr>
+                        <a:t>35.7 %</a:t>
                       </a:r>
                       <a:endParaRPr lang="en-US" sz="1400" dirty="0">
                         <a:latin typeface="Calibri" charset="0"/>
@@ -17232,7 +19685,7 @@
                 <a:ea typeface="Calibri" pitchFamily="34" charset="-122"/>
                 <a:cs typeface="Calibri" pitchFamily="34" charset="-120"/>
               </a:rPr>
-              <a:t>Spread = how much grams per unit of the feature varies between piles; lower is better.</a:t>
+              <a:t>r = correlation with the weight (1 = perfect line). Spread = how much grams per unit of the feature varies between piles; lower is better. How many piles we need: slide 13.</a:t>
             </a:r>
             <a:endParaRPr lang="en-US" sz="1200" dirty="0"/>
           </a:p>
@@ -17717,7 +20170,7 @@
                 <a:ea typeface="Calibri" pitchFamily="34" charset="-122"/>
                 <a:cs typeface="Calibri" pitchFamily="34" charset="-120"/>
               </a:rPr>
-              <a:t>Parts add as squares: 3.97^2 = 1.73^2 + 0.93^2 + 3.45^2. The remainder is found by subtraction, not measured.</a:t>
+              <a:t>Relative standard deviation = typical error as % of the weight. Parts add as squares: 3.97² = 1.73² + 0.93² + 3.45². The remainder is found by subtraction, not measured.</a:t>
             </a:r>
             <a:endParaRPr lang="en-US" sz="1200" dirty="0"/>
           </a:p>
@@ -17830,7 +20283,7 @@
                 <a:ea typeface="Calibri" pitchFamily="34" charset="-122"/>
                 <a:cs typeface="Calibri" pitchFamily="34" charset="-120"/>
               </a:rPr>
-              <a:t>= 2.12 x 3.97 % x 1.03 = ±8.7 %</a:t>
+              <a:t>= 2.12 x 3.97 % x 1.03 = ±8.7 %</a:t>
             </a:r>
             <a:endParaRPr lang="en-US" sz="1600" dirty="0"/>
           </a:p>
@@ -17943,7 +20396,7 @@
                 <a:ea typeface="Calibri" pitchFamily="34" charset="-122"/>
                 <a:cs typeface="Calibri" pitchFamily="34" charset="-120"/>
               </a:rPr>
-              <a:t>The photo is no longer the main error (0.9 %).</a:t>
+              <a:t>The photo is no longer the main error (0.9 %).</a:t>
             </a:r>
             <a:endParaRPr lang="en-US" sz="1600" dirty="0"/>
           </a:p>

</xml_diff>